<commit_message>
MOVA Paso 3: solicitud n8n (tabla + JSON + capturas) con guía HTML y mockups
Co-authored-by: JosefaOgalde <JosefaOgalde@users.noreply.github.com>
</commit_message>
<xml_diff>
--- a/index/clientes/mkof/MOVA-GitHub-N8n-Checklist.pptx
+++ b/index/clientes/mkof/MOVA-GitHub-N8n-Checklist.pptx
@@ -20,6 +20,8 @@
     <p:sldId id="268" r:id="rId19"/>
     <p:sldId id="269" r:id="rId20"/>
     <p:sldId id="270" r:id="rId21"/>
+    <p:sldId id="271" r:id="rId22"/>
+    <p:sldId id="272" r:id="rId23"/>
   </p:sldIdLst>
   <p:sldSz cx="12191695" cy="6858000" type="screen4x3"/>
   <p:notesSz cx="6858000" cy="9144000"/>
@@ -3245,7 +3247,7 @@
               </a:defRPr>
             </a:pPr>
             <a:r>
-              <a:t>Cuenta GitHub → repo privado mova-n8n-workflows → pedidos al equipo n8n</a:t>
+              <a:t>Paso 1 cuenta → Paso 2 repo → Paso 3 solicitud n8n (tabla + JSON + capturas)</a:t>
             </a:r>
           </a:p>
         </p:txBody>
@@ -4021,7 +4023,7 @@
               </a:defRPr>
             </a:pPr>
             <a:r>
-              <a:t>Bloque C · Pedido 3 — Contexto</a:t>
+              <a:t>Paso 3 · Pedido 3 — Capturas n8n</a:t>
             </a:r>
           </a:p>
         </p:txBody>
@@ -4056,7 +4058,7 @@
               </a:defRPr>
             </a:pPr>
             <a:r>
-              <a:t>Información complementaria</a:t>
+              <a:t>Entender el flujo visual por workflow</a:t>
             </a:r>
           </a:p>
         </p:txBody>
@@ -4134,23 +4136,23 @@
               </a:defRPr>
             </a:pPr>
             <a:r>
-              <a:t>C3</a:t>
-            </a:r>
-          </a:p>
-        </p:txBody>
-      </p:sp>
-      <p:sp>
-        <p:nvSpPr>
-          <p:cNvPr id="7" name="Rounded Rectangle 6"/>
+              <a:t>3</a:t>
+            </a:r>
+          </a:p>
+        </p:txBody>
+      </p:sp>
+      <p:sp>
+        <p:nvSpPr>
+          <p:cNvPr id="7" name="Oval 6"/>
           <p:cNvSpPr/>
           <p:nvPr/>
         </p:nvSpPr>
         <p:spPr>
           <a:xfrm>
-            <a:off x="685800" y="1280160"/>
-            <a:ext cx="2194560" cy="640080"/>
-          </a:xfrm>
-          <a:prstGeom prst="roundRect">
+            <a:off x="640080" y="1234440"/>
+            <a:ext cx="347472" cy="347472"/>
+          </a:xfrm>
+          <a:prstGeom prst="ellipse">
             <a:avLst/>
           </a:prstGeom>
           <a:solidFill>
@@ -4190,8 +4192,8 @@
         </p:nvSpPr>
         <p:spPr>
           <a:xfrm>
-            <a:off x="685800" y="1481328"/>
-            <a:ext cx="2194560" cy="320040"/>
+            <a:off x="640080" y="1280160"/>
+            <a:ext cx="347472" cy="256032"/>
           </a:xfrm>
           <a:prstGeom prst="rect">
             <a:avLst/>
@@ -4205,14 +4207,14 @@
           <a:lstStyle/>
           <a:p>
             <a:pPr algn="ctr">
-              <a:defRPr sz="1000" b="1">
+              <a:defRPr sz="1200" b="1">
                 <a:solidFill>
                   <a:srgbClr val="FFFFFF"/>
                 </a:solidFill>
               </a:defRPr>
             </a:pPr>
             <a:r>
-              <a:t>URL instancia n8n</a:t>
+              <a:t>1</a:t>
             </a:r>
           </a:p>
         </p:txBody>
@@ -4225,8 +4227,8 @@
         </p:nvSpPr>
         <p:spPr>
           <a:xfrm>
-            <a:off x="3063240" y="1280160"/>
-            <a:ext cx="8412480" cy="640080"/>
+            <a:off x="1097280" y="1188720"/>
+            <a:ext cx="10515600" cy="658368"/>
           </a:xfrm>
           <a:prstGeom prst="roundRect">
             <a:avLst/>
@@ -4236,7 +4238,7 @@
           </a:solidFill>
           <a:ln w="12700">
             <a:solidFill>
-              <a:srgbClr val="656D76"/>
+              <a:srgbClr val="4A7A80"/>
             </a:solidFill>
           </a:ln>
         </p:spPr>
@@ -4270,45 +4272,80 @@
         </p:nvSpPr>
         <p:spPr>
           <a:xfrm>
-            <a:off x="3200400" y="1463040"/>
-            <a:ext cx="8138160" cy="320040"/>
-          </a:xfrm>
-          <a:prstGeom prst="rect">
-            <a:avLst/>
-          </a:prstGeom>
-          <a:noFill/>
-        </p:spPr>
-        <p:txBody>
-          <a:bodyPr wrap="square">
-            <a:spAutoFit/>
-          </a:bodyPr>
-          <a:lstStyle/>
-          <a:p>
-            <a:pPr algn="l">
-              <a:defRPr sz="1200" b="0">
-                <a:solidFill>
-                  <a:srgbClr val="1F2328"/>
-                </a:solidFill>
-              </a:defRPr>
-            </a:pPr>
-            <a:r>
-              <a:t>Ej. n8n.empresa.cl — dónde administran.</a:t>
-            </a:r>
-          </a:p>
-        </p:txBody>
-      </p:sp>
-      <p:sp>
-        <p:nvSpPr>
-          <p:cNvPr id="11" name="Rounded Rectangle 10"/>
+            <a:off x="1234440" y="1243584"/>
+            <a:ext cx="10241280" cy="256032"/>
+          </a:xfrm>
+          <a:prstGeom prst="rect">
+            <a:avLst/>
+          </a:prstGeom>
+          <a:noFill/>
+        </p:spPr>
+        <p:txBody>
+          <a:bodyPr wrap="square">
+            <a:spAutoFit/>
+          </a:bodyPr>
+          <a:lstStyle/>
+          <a:p>
+            <a:pPr algn="l">
+              <a:defRPr sz="1200" b="1">
+                <a:solidFill>
+                  <a:srgbClr val="2A4A4E"/>
+                </a:solidFill>
+              </a:defRPr>
+            </a:pPr>
+            <a:r>
+              <a:t>Lista workflows</a:t>
+            </a:r>
+          </a:p>
+        </p:txBody>
+      </p:sp>
+      <p:sp>
+        <p:nvSpPr>
+          <p:cNvPr id="11" name="TextBox 10"/>
+          <p:cNvSpPr txBox="1"/>
+          <p:nvPr/>
+        </p:nvSpPr>
+        <p:spPr>
+          <a:xfrm>
+            <a:off x="1234440" y="1499616"/>
+            <a:ext cx="10241280" cy="292608"/>
+          </a:xfrm>
+          <a:prstGeom prst="rect">
+            <a:avLst/>
+          </a:prstGeom>
+          <a:noFill/>
+        </p:spPr>
+        <p:txBody>
+          <a:bodyPr wrap="square">
+            <a:spAutoFit/>
+          </a:bodyPr>
+          <a:lstStyle/>
+          <a:p>
+            <a:pPr algn="l">
+              <a:defRPr sz="1000" b="0">
+                <a:solidFill>
+                  <a:srgbClr val="656D76"/>
+                </a:solidFill>
+              </a:defRPr>
+            </a:pPr>
+            <a:r>
+              <a:t>Captura de n8n con workflows activos (ON) visibles.</a:t>
+            </a:r>
+          </a:p>
+        </p:txBody>
+      </p:sp>
+      <p:sp>
+        <p:nvSpPr>
+          <p:cNvPr id="12" name="Oval 11"/>
           <p:cNvSpPr/>
           <p:nvPr/>
         </p:nvSpPr>
         <p:spPr>
           <a:xfrm>
-            <a:off x="685800" y="2029968"/>
-            <a:ext cx="2194560" cy="640080"/>
-          </a:xfrm>
-          <a:prstGeom prst="roundRect">
+            <a:off x="640080" y="1984248"/>
+            <a:ext cx="347472" cy="347472"/>
+          </a:xfrm>
+          <a:prstGeom prst="ellipse">
             <a:avLst/>
           </a:prstGeom>
           <a:solidFill>
@@ -4342,14 +4379,14 @@
       </p:sp>
       <p:sp>
         <p:nvSpPr>
-          <p:cNvPr id="12" name="TextBox 11"/>
-          <p:cNvSpPr txBox="1"/>
-          <p:nvPr/>
-        </p:nvSpPr>
-        <p:spPr>
-          <a:xfrm>
-            <a:off x="685800" y="2231136"/>
-            <a:ext cx="2194560" cy="320040"/>
+          <p:cNvPr id="13" name="TextBox 12"/>
+          <p:cNvSpPr txBox="1"/>
+          <p:nvPr/>
+        </p:nvSpPr>
+        <p:spPr>
+          <a:xfrm>
+            <a:off x="640080" y="2029968"/>
+            <a:ext cx="347472" cy="256032"/>
           </a:xfrm>
           <a:prstGeom prst="rect">
             <a:avLst/>
@@ -4363,28 +4400,28 @@
           <a:lstStyle/>
           <a:p>
             <a:pPr algn="ctr">
-              <a:defRPr sz="1000" b="1">
+              <a:defRPr sz="1200" b="1">
                 <a:solidFill>
                   <a:srgbClr val="FFFFFF"/>
                 </a:solidFill>
               </a:defRPr>
             </a:pPr>
             <a:r>
-              <a:t>Admin / contacto</a:t>
-            </a:r>
-          </a:p>
-        </p:txBody>
-      </p:sp>
-      <p:sp>
-        <p:nvSpPr>
-          <p:cNvPr id="13" name="Rounded Rectangle 12"/>
+              <a:t>2</a:t>
+            </a:r>
+          </a:p>
+        </p:txBody>
+      </p:sp>
+      <p:sp>
+        <p:nvSpPr>
+          <p:cNvPr id="14" name="Rounded Rectangle 13"/>
           <p:cNvSpPr/>
           <p:nvPr/>
         </p:nvSpPr>
         <p:spPr>
           <a:xfrm>
-            <a:off x="3063240" y="2029968"/>
-            <a:ext cx="8412480" cy="640080"/>
+            <a:off x="1097280" y="1938528"/>
+            <a:ext cx="10515600" cy="658368"/>
           </a:xfrm>
           <a:prstGeom prst="roundRect">
             <a:avLst/>
@@ -4394,7 +4431,7 @@
           </a:solidFill>
           <a:ln w="12700">
             <a:solidFill>
-              <a:srgbClr val="656D76"/>
+              <a:srgbClr val="4A7A80"/>
             </a:solidFill>
           </a:ln>
         </p:spPr>
@@ -4422,51 +4459,86 @@
       </p:sp>
       <p:sp>
         <p:nvSpPr>
-          <p:cNvPr id="14" name="TextBox 13"/>
-          <p:cNvSpPr txBox="1"/>
-          <p:nvPr/>
-        </p:nvSpPr>
-        <p:spPr>
-          <a:xfrm>
-            <a:off x="3200400" y="2212848"/>
-            <a:ext cx="8138160" cy="320040"/>
-          </a:xfrm>
-          <a:prstGeom prst="rect">
-            <a:avLst/>
-          </a:prstGeom>
-          <a:noFill/>
-        </p:spPr>
-        <p:txBody>
-          <a:bodyPr wrap="square">
-            <a:spAutoFit/>
-          </a:bodyPr>
-          <a:lstStyle/>
-          <a:p>
-            <a:pPr algn="l">
-              <a:defRPr sz="1200" b="0">
-                <a:solidFill>
-                  <a:srgbClr val="1F2328"/>
-                </a:solidFill>
-              </a:defRPr>
-            </a:pPr>
-            <a:r>
-              <a:t>Quién tiene acceso admin para cambios futuros.</a:t>
-            </a:r>
-          </a:p>
-        </p:txBody>
-      </p:sp>
-      <p:sp>
-        <p:nvSpPr>
-          <p:cNvPr id="15" name="Rounded Rectangle 14"/>
+          <p:cNvPr id="15" name="TextBox 14"/>
+          <p:cNvSpPr txBox="1"/>
+          <p:nvPr/>
+        </p:nvSpPr>
+        <p:spPr>
+          <a:xfrm>
+            <a:off x="1234440" y="1993392"/>
+            <a:ext cx="10241280" cy="256032"/>
+          </a:xfrm>
+          <a:prstGeom prst="rect">
+            <a:avLst/>
+          </a:prstGeom>
+          <a:noFill/>
+        </p:spPr>
+        <p:txBody>
+          <a:bodyPr wrap="square">
+            <a:spAutoFit/>
+          </a:bodyPr>
+          <a:lstStyle/>
+          <a:p>
+            <a:pPr algn="l">
+              <a:defRPr sz="1200" b="1">
+                <a:solidFill>
+                  <a:srgbClr val="2A4A4E"/>
+                </a:solidFill>
+              </a:defRPr>
+            </a:pPr>
+            <a:r>
+              <a:t>Canvas completo</a:t>
+            </a:r>
+          </a:p>
+        </p:txBody>
+      </p:sp>
+      <p:sp>
+        <p:nvSpPr>
+          <p:cNvPr id="16" name="TextBox 15"/>
+          <p:cNvSpPr txBox="1"/>
+          <p:nvPr/>
+        </p:nvSpPr>
+        <p:spPr>
+          <a:xfrm>
+            <a:off x="1234440" y="2249424"/>
+            <a:ext cx="10241280" cy="292608"/>
+          </a:xfrm>
+          <a:prstGeom prst="rect">
+            <a:avLst/>
+          </a:prstGeom>
+          <a:noFill/>
+        </p:spPr>
+        <p:txBody>
+          <a:bodyPr wrap="square">
+            <a:spAutoFit/>
+          </a:bodyPr>
+          <a:lstStyle/>
+          <a:p>
+            <a:pPr algn="l">
+              <a:defRPr sz="1000" b="0">
+                <a:solidFill>
+                  <a:srgbClr val="656D76"/>
+                </a:solidFill>
+              </a:defRPr>
+            </a:pPr>
+            <a:r>
+              <a:t>Por workflow: todos los nodos — trigger → lógica → respuesta.</a:t>
+            </a:r>
+          </a:p>
+        </p:txBody>
+      </p:sp>
+      <p:sp>
+        <p:nvSpPr>
+          <p:cNvPr id="17" name="Oval 16"/>
           <p:cNvSpPr/>
           <p:nvPr/>
         </p:nvSpPr>
         <p:spPr>
           <a:xfrm>
-            <a:off x="685800" y="2779776"/>
-            <a:ext cx="2194560" cy="640080"/>
-          </a:xfrm>
-          <a:prstGeom prst="roundRect">
+            <a:off x="640080" y="2734056"/>
+            <a:ext cx="347472" cy="347472"/>
+          </a:xfrm>
+          <a:prstGeom prst="ellipse">
             <a:avLst/>
           </a:prstGeom>
           <a:solidFill>
@@ -4500,14 +4572,14 @@
       </p:sp>
       <p:sp>
         <p:nvSpPr>
-          <p:cNvPr id="16" name="TextBox 15"/>
-          <p:cNvSpPr txBox="1"/>
-          <p:nvPr/>
-        </p:nvSpPr>
-        <p:spPr>
-          <a:xfrm>
-            <a:off x="685800" y="2980944"/>
-            <a:ext cx="2194560" cy="320040"/>
+          <p:cNvPr id="18" name="TextBox 17"/>
+          <p:cNvSpPr txBox="1"/>
+          <p:nvPr/>
+        </p:nvSpPr>
+        <p:spPr>
+          <a:xfrm>
+            <a:off x="640080" y="2779776"/>
+            <a:ext cx="347472" cy="256032"/>
           </a:xfrm>
           <a:prstGeom prst="rect">
             <a:avLst/>
@@ -4521,28 +4593,28 @@
           <a:lstStyle/>
           <a:p>
             <a:pPr algn="ctr">
-              <a:defRPr sz="1000" b="1">
+              <a:defRPr sz="1200" b="1">
                 <a:solidFill>
                   <a:srgbClr val="FFFFFF"/>
                 </a:solidFill>
               </a:defRPr>
             </a:pPr>
             <a:r>
-              <a:t>Webhooks sin auth</a:t>
-            </a:r>
-          </a:p>
-        </p:txBody>
-      </p:sp>
-      <p:sp>
-        <p:nvSpPr>
-          <p:cNvPr id="17" name="Rounded Rectangle 16"/>
+              <a:t>3</a:t>
+            </a:r>
+          </a:p>
+        </p:txBody>
+      </p:sp>
+      <p:sp>
+        <p:nvSpPr>
+          <p:cNvPr id="19" name="Rounded Rectangle 18"/>
           <p:cNvSpPr/>
           <p:nvPr/>
         </p:nvSpPr>
         <p:spPr>
           <a:xfrm>
-            <a:off x="3063240" y="2779776"/>
-            <a:ext cx="8412480" cy="640080"/>
+            <a:off x="1097280" y="2688336"/>
+            <a:ext cx="10515600" cy="658368"/>
           </a:xfrm>
           <a:prstGeom prst="roundRect">
             <a:avLst/>
@@ -4552,7 +4624,7 @@
           </a:solidFill>
           <a:ln w="12700">
             <a:solidFill>
-              <a:srgbClr val="656D76"/>
+              <a:srgbClr val="4A7A80"/>
             </a:solidFill>
           </a:ln>
         </p:spPr>
@@ -4580,51 +4652,86 @@
       </p:sp>
       <p:sp>
         <p:nvSpPr>
-          <p:cNvPr id="18" name="TextBox 17"/>
-          <p:cNvSpPr txBox="1"/>
-          <p:nvPr/>
-        </p:nvSpPr>
-        <p:spPr>
-          <a:xfrm>
-            <a:off x="3200400" y="2962656"/>
-            <a:ext cx="8138160" cy="320040"/>
-          </a:xfrm>
-          <a:prstGeom prst="rect">
-            <a:avLst/>
-          </a:prstGeom>
-          <a:noFill/>
-        </p:spPr>
-        <p:txBody>
-          <a:bodyPr wrap="square">
-            <a:spAutoFit/>
-          </a:bodyPr>
-          <a:lstStyle/>
-          <a:p>
-            <a:pPr algn="l">
-              <a:defRPr sz="1200" b="0">
-                <a:solidFill>
-                  <a:srgbClr val="1F2328"/>
-                </a:solidFill>
-              </a:defRPr>
-            </a:pPr>
-            <a:r>
-              <a:t>¿Algún endpoint público sin validación? — riesgo a documentar.</a:t>
-            </a:r>
-          </a:p>
-        </p:txBody>
-      </p:sp>
-      <p:sp>
-        <p:nvSpPr>
-          <p:cNvPr id="19" name="Rounded Rectangle 18"/>
+          <p:cNvPr id="20" name="TextBox 19"/>
+          <p:cNvSpPr txBox="1"/>
+          <p:nvPr/>
+        </p:nvSpPr>
+        <p:spPr>
+          <a:xfrm>
+            <a:off x="1234440" y="2743200"/>
+            <a:ext cx="10241280" cy="256032"/>
+          </a:xfrm>
+          <a:prstGeom prst="rect">
+            <a:avLst/>
+          </a:prstGeom>
+          <a:noFill/>
+        </p:spPr>
+        <p:txBody>
+          <a:bodyPr wrap="square">
+            <a:spAutoFit/>
+          </a:bodyPr>
+          <a:lstStyle/>
+          <a:p>
+            <a:pPr algn="l">
+              <a:defRPr sz="1200" b="1">
+                <a:solidFill>
+                  <a:srgbClr val="2A4A4E"/>
+                </a:solidFill>
+              </a:defRPr>
+            </a:pPr>
+            <a:r>
+              <a:t>Nodo Webhook</a:t>
+            </a:r>
+          </a:p>
+        </p:txBody>
+      </p:sp>
+      <p:sp>
+        <p:nvSpPr>
+          <p:cNvPr id="21" name="TextBox 20"/>
+          <p:cNvSpPr txBox="1"/>
+          <p:nvPr/>
+        </p:nvSpPr>
+        <p:spPr>
+          <a:xfrm>
+            <a:off x="1234440" y="2999232"/>
+            <a:ext cx="10241280" cy="292608"/>
+          </a:xfrm>
+          <a:prstGeom prst="rect">
+            <a:avLst/>
+          </a:prstGeom>
+          <a:noFill/>
+        </p:spPr>
+        <p:txBody>
+          <a:bodyPr wrap="square">
+            <a:spAutoFit/>
+          </a:bodyPr>
+          <a:lstStyle/>
+          <a:p>
+            <a:pPr algn="l">
+              <a:defRPr sz="1000" b="0">
+                <a:solidFill>
+                  <a:srgbClr val="656D76"/>
+                </a:solidFill>
+              </a:defRPr>
+            </a:pPr>
+            <a:r>
+              <a:t>Panel del webhook: URL producción, método HTTP, path.</a:t>
+            </a:r>
+          </a:p>
+        </p:txBody>
+      </p:sp>
+      <p:sp>
+        <p:nvSpPr>
+          <p:cNvPr id="22" name="Oval 21"/>
           <p:cNvSpPr/>
           <p:nvPr/>
         </p:nvSpPr>
         <p:spPr>
           <a:xfrm>
-            <a:off x="685800" y="3529584"/>
-            <a:ext cx="2194560" cy="640080"/>
-          </a:xfrm>
-          <a:prstGeom prst="roundRect">
+            <a:off x="640080" y="3483864"/>
+            <a:ext cx="347472" cy="347472"/>
+          </a:xfrm>
+          <a:prstGeom prst="ellipse">
             <a:avLst/>
           </a:prstGeom>
           <a:solidFill>
@@ -4658,14 +4765,14 @@
       </p:sp>
       <p:sp>
         <p:nvSpPr>
-          <p:cNvPr id="20" name="TextBox 19"/>
-          <p:cNvSpPr txBox="1"/>
-          <p:nvPr/>
-        </p:nvSpPr>
-        <p:spPr>
-          <a:xfrm>
-            <a:off x="685800" y="3730752"/>
-            <a:ext cx="2194560" cy="320040"/>
+          <p:cNvPr id="23" name="TextBox 22"/>
+          <p:cNvSpPr txBox="1"/>
+          <p:nvPr/>
+        </p:nvSpPr>
+        <p:spPr>
+          <a:xfrm>
+            <a:off x="640080" y="3529584"/>
+            <a:ext cx="347472" cy="256032"/>
           </a:xfrm>
           <a:prstGeom prst="rect">
             <a:avLst/>
@@ -4679,28 +4786,28 @@
           <a:lstStyle/>
           <a:p>
             <a:pPr algn="ctr">
-              <a:defRPr sz="1000" b="1">
+              <a:defRPr sz="1200" b="1">
                 <a:solidFill>
                   <a:srgbClr val="FFFFFF"/>
                 </a:solidFill>
               </a:defRPr>
             </a:pPr>
             <a:r>
-              <a:t>Validación de usuario</a:t>
-            </a:r>
-          </a:p>
-        </p:txBody>
-      </p:sp>
-      <p:sp>
-        <p:nvSpPr>
-          <p:cNvPr id="21" name="Rounded Rectangle 20"/>
+              <a:t>4</a:t>
+            </a:r>
+          </a:p>
+        </p:txBody>
+      </p:sp>
+      <p:sp>
+        <p:nvSpPr>
+          <p:cNvPr id="24" name="Rounded Rectangle 23"/>
           <p:cNvSpPr/>
           <p:nvPr/>
         </p:nvSpPr>
         <p:spPr>
           <a:xfrm>
-            <a:off x="3063240" y="3529584"/>
-            <a:ext cx="8412480" cy="640080"/>
+            <a:off x="1097280" y="3438144"/>
+            <a:ext cx="10515600" cy="658368"/>
           </a:xfrm>
           <a:prstGeom prst="roundRect">
             <a:avLst/>
@@ -4710,7 +4817,7 @@
           </a:solidFill>
           <a:ln w="12700">
             <a:solidFill>
-              <a:srgbClr val="656D76"/>
+              <a:srgbClr val="4A7A80"/>
             </a:solidFill>
           </a:ln>
         </p:spPr>
@@ -4738,51 +4845,86 @@
       </p:sp>
       <p:sp>
         <p:nvSpPr>
-          <p:cNvPr id="22" name="TextBox 21"/>
-          <p:cNvSpPr txBox="1"/>
-          <p:nvPr/>
-        </p:nvSpPr>
-        <p:spPr>
-          <a:xfrm>
-            <a:off x="3200400" y="3712464"/>
-            <a:ext cx="8138160" cy="320040"/>
-          </a:xfrm>
-          <a:prstGeom prst="rect">
-            <a:avLst/>
-          </a:prstGeom>
-          <a:noFill/>
-        </p:spPr>
-        <p:txBody>
-          <a:bodyPr wrap="square">
-            <a:spAutoFit/>
-          </a:bodyPr>
-          <a:lstStyle/>
-          <a:p>
-            <a:pPr algn="l">
-              <a:defRPr sz="1200" b="0">
-                <a:solidFill>
-                  <a:srgbClr val="1F2328"/>
-                </a:solidFill>
-              </a:defRPr>
-            </a:pPr>
-            <a:r>
-              <a:t>¿Algún workflow valida sesión/token de usuario? (clave para D5).</a:t>
-            </a:r>
-          </a:p>
-        </p:txBody>
-      </p:sp>
-      <p:sp>
-        <p:nvSpPr>
-          <p:cNvPr id="23" name="Rounded Rectangle 22"/>
+          <p:cNvPr id="25" name="TextBox 24"/>
+          <p:cNvSpPr txBox="1"/>
+          <p:nvPr/>
+        </p:nvSpPr>
+        <p:spPr>
+          <a:xfrm>
+            <a:off x="1234440" y="3493008"/>
+            <a:ext cx="10241280" cy="256032"/>
+          </a:xfrm>
+          <a:prstGeom prst="rect">
+            <a:avLst/>
+          </a:prstGeom>
+          <a:noFill/>
+        </p:spPr>
+        <p:txBody>
+          <a:bodyPr wrap="square">
+            <a:spAutoFit/>
+          </a:bodyPr>
+          <a:lstStyle/>
+          <a:p>
+            <a:pPr algn="l">
+              <a:defRPr sz="1200" b="1">
+                <a:solidFill>
+                  <a:srgbClr val="2A4A4E"/>
+                </a:solidFill>
+              </a:defRPr>
+            </a:pPr>
+            <a:r>
+              <a:t>Validación auth</a:t>
+            </a:r>
+          </a:p>
+        </p:txBody>
+      </p:sp>
+      <p:sp>
+        <p:nvSpPr>
+          <p:cNvPr id="26" name="TextBox 25"/>
+          <p:cNvSpPr txBox="1"/>
+          <p:nvPr/>
+        </p:nvSpPr>
+        <p:spPr>
+          <a:xfrm>
+            <a:off x="1234440" y="3749040"/>
+            <a:ext cx="10241280" cy="292608"/>
+          </a:xfrm>
+          <a:prstGeom prst="rect">
+            <a:avLst/>
+          </a:prstGeom>
+          <a:noFill/>
+        </p:spPr>
+        <p:txBody>
+          <a:bodyPr wrap="square">
+            <a:spAutoFit/>
+          </a:bodyPr>
+          <a:lstStyle/>
+          <a:p>
+            <a:pPr algn="l">
+              <a:defRPr sz="1000" b="0">
+                <a:solidFill>
+                  <a:srgbClr val="656D76"/>
+                </a:solidFill>
+              </a:defRPr>
+            </a:pPr>
+            <a:r>
+              <a:t>Nodos IF/Code donde validan token o usuario (clave D5).</a:t>
+            </a:r>
+          </a:p>
+        </p:txBody>
+      </p:sp>
+      <p:sp>
+        <p:nvSpPr>
+          <p:cNvPr id="27" name="Oval 26"/>
           <p:cNvSpPr/>
           <p:nvPr/>
         </p:nvSpPr>
         <p:spPr>
           <a:xfrm>
-            <a:off x="685800" y="4279392"/>
-            <a:ext cx="2194560" cy="640080"/>
-          </a:xfrm>
-          <a:prstGeom prst="roundRect">
+            <a:off x="640080" y="4233672"/>
+            <a:ext cx="347472" cy="347472"/>
+          </a:xfrm>
+          <a:prstGeom prst="ellipse">
             <a:avLst/>
           </a:prstGeom>
           <a:solidFill>
@@ -4816,14 +4958,14 @@
       </p:sp>
       <p:sp>
         <p:nvSpPr>
-          <p:cNvPr id="24" name="TextBox 23"/>
-          <p:cNvSpPr txBox="1"/>
-          <p:nvPr/>
-        </p:nvSpPr>
-        <p:spPr>
-          <a:xfrm>
-            <a:off x="685800" y="4480560"/>
-            <a:ext cx="2194560" cy="320040"/>
+          <p:cNvPr id="28" name="TextBox 27"/>
+          <p:cNvSpPr txBox="1"/>
+          <p:nvPr/>
+        </p:nvSpPr>
+        <p:spPr>
+          <a:xfrm>
+            <a:off x="640080" y="4279392"/>
+            <a:ext cx="347472" cy="256032"/>
           </a:xfrm>
           <a:prstGeom prst="rect">
             <a:avLst/>
@@ -4837,28 +4979,28 @@
           <a:lstStyle/>
           <a:p>
             <a:pPr algn="ctr">
-              <a:defRPr sz="1000" b="1">
+              <a:defRPr sz="1200" b="1">
                 <a:solidFill>
                   <a:srgbClr val="FFFFFF"/>
                 </a:solidFill>
               </a:defRPr>
             </a:pPr>
             <a:r>
-              <a:t>Backup automático</a:t>
-            </a:r>
-          </a:p>
-        </p:txBody>
-      </p:sp>
-      <p:sp>
-        <p:nvSpPr>
-          <p:cNvPr id="25" name="Rounded Rectangle 24"/>
+              <a:t>5</a:t>
+            </a:r>
+          </a:p>
+        </p:txBody>
+      </p:sp>
+      <p:sp>
+        <p:nvSpPr>
+          <p:cNvPr id="29" name="Rounded Rectangle 28"/>
           <p:cNvSpPr/>
           <p:nvPr/>
         </p:nvSpPr>
         <p:spPr>
           <a:xfrm>
-            <a:off x="3063240" y="4279392"/>
-            <a:ext cx="8412480" cy="640080"/>
+            <a:off x="1097280" y="4187952"/>
+            <a:ext cx="10515600" cy="658368"/>
           </a:xfrm>
           <a:prstGeom prst="roundRect">
             <a:avLst/>
@@ -4868,7 +5010,7 @@
           </a:solidFill>
           <a:ln w="12700">
             <a:solidFill>
-              <a:srgbClr val="656D76"/>
+              <a:srgbClr val="4A7A80"/>
             </a:solidFill>
           </a:ln>
         </p:spPr>
@@ -4896,35 +5038,343 @@
       </p:sp>
       <p:sp>
         <p:nvSpPr>
-          <p:cNvPr id="26" name="TextBox 25"/>
-          <p:cNvSpPr txBox="1"/>
-          <p:nvPr/>
-        </p:nvSpPr>
-        <p:spPr>
-          <a:xfrm>
-            <a:off x="3200400" y="4462272"/>
-            <a:ext cx="8138160" cy="320040"/>
-          </a:xfrm>
-          <a:prstGeom prst="rect">
-            <a:avLst/>
-          </a:prstGeom>
-          <a:noFill/>
-        </p:spPr>
-        <p:txBody>
-          <a:bodyPr wrap="square">
-            <a:spAutoFit/>
-          </a:bodyPr>
-          <a:lstStyle/>
-          <a:p>
-            <a:pPr algn="l">
-              <a:defRPr sz="1200" b="0">
-                <a:solidFill>
-                  <a:srgbClr val="1F2328"/>
-                </a:solidFill>
-              </a:defRPr>
-            </a:pPr>
-            <a:r>
-              <a:t>¿Existe sync a GitHub o hay que configurarlo después del repo?</a:t>
+          <p:cNvPr id="30" name="TextBox 29"/>
+          <p:cNvSpPr txBox="1"/>
+          <p:nvPr/>
+        </p:nvSpPr>
+        <p:spPr>
+          <a:xfrm>
+            <a:off x="1234440" y="4242816"/>
+            <a:ext cx="10241280" cy="256032"/>
+          </a:xfrm>
+          <a:prstGeom prst="rect">
+            <a:avLst/>
+          </a:prstGeom>
+          <a:noFill/>
+        </p:spPr>
+        <p:txBody>
+          <a:bodyPr wrap="square">
+            <a:spAutoFit/>
+          </a:bodyPr>
+          <a:lstStyle/>
+          <a:p>
+            <a:pPr algn="l">
+              <a:defRPr sz="1200" b="1">
+                <a:solidFill>
+                  <a:srgbClr val="2A4A4E"/>
+                </a:solidFill>
+              </a:defRPr>
+            </a:pPr>
+            <a:r>
+              <a:t>Executions</a:t>
+            </a:r>
+          </a:p>
+        </p:txBody>
+      </p:sp>
+      <p:sp>
+        <p:nvSpPr>
+          <p:cNvPr id="31" name="TextBox 30"/>
+          <p:cNvSpPr txBox="1"/>
+          <p:nvPr/>
+        </p:nvSpPr>
+        <p:spPr>
+          <a:xfrm>
+            <a:off x="1234440" y="4498848"/>
+            <a:ext cx="10241280" cy="292608"/>
+          </a:xfrm>
+          <a:prstGeom prst="rect">
+            <a:avLst/>
+          </a:prstGeom>
+          <a:noFill/>
+        </p:spPr>
+        <p:txBody>
+          <a:bodyPr wrap="square">
+            <a:spAutoFit/>
+          </a:bodyPr>
+          <a:lstStyle/>
+          <a:p>
+            <a:pPr algn="l">
+              <a:defRPr sz="1000" b="0">
+                <a:solidFill>
+                  <a:srgbClr val="656D76"/>
+                </a:solidFill>
+              </a:defRPr>
+            </a:pPr>
+            <a:r>
+              <a:t>Opcional: ejecución Success reciente — tapar datos sensibles.</a:t>
+            </a:r>
+          </a:p>
+        </p:txBody>
+      </p:sp>
+      <p:sp>
+        <p:nvSpPr>
+          <p:cNvPr id="32" name="Oval 31"/>
+          <p:cNvSpPr/>
+          <p:nvPr/>
+        </p:nvSpPr>
+        <p:spPr>
+          <a:xfrm>
+            <a:off x="640080" y="4983480"/>
+            <a:ext cx="347472" cy="347472"/>
+          </a:xfrm>
+          <a:prstGeom prst="ellipse">
+            <a:avLst/>
+          </a:prstGeom>
+          <a:solidFill>
+            <a:srgbClr val="4A7A80"/>
+          </a:solidFill>
+          <a:ln>
+            <a:noFill/>
+          </a:ln>
+        </p:spPr>
+        <p:style>
+          <a:lnRef idx="1">
+            <a:schemeClr val="accent1"/>
+          </a:lnRef>
+          <a:fillRef idx="3">
+            <a:schemeClr val="accent1"/>
+          </a:fillRef>
+          <a:effectRef idx="2">
+            <a:schemeClr val="accent1"/>
+          </a:effectRef>
+          <a:fontRef idx="minor">
+            <a:schemeClr val="lt1"/>
+          </a:fontRef>
+        </p:style>
+        <p:txBody>
+          <a:bodyPr rtlCol="0" anchor="ctr"/>
+          <a:lstStyle/>
+          <a:p>
+            <a:pPr algn="ctr"/>
+          </a:p>
+        </p:txBody>
+      </p:sp>
+      <p:sp>
+        <p:nvSpPr>
+          <p:cNvPr id="33" name="TextBox 32"/>
+          <p:cNvSpPr txBox="1"/>
+          <p:nvPr/>
+        </p:nvSpPr>
+        <p:spPr>
+          <a:xfrm>
+            <a:off x="640080" y="5029200"/>
+            <a:ext cx="347472" cy="256032"/>
+          </a:xfrm>
+          <a:prstGeom prst="rect">
+            <a:avLst/>
+          </a:prstGeom>
+          <a:noFill/>
+        </p:spPr>
+        <p:txBody>
+          <a:bodyPr wrap="square">
+            <a:spAutoFit/>
+          </a:bodyPr>
+          <a:lstStyle/>
+          <a:p>
+            <a:pPr algn="ctr">
+              <a:defRPr sz="1200" b="1">
+                <a:solidFill>
+                  <a:srgbClr val="FFFFFF"/>
+                </a:solidFill>
+              </a:defRPr>
+            </a:pPr>
+            <a:r>
+              <a:t>6</a:t>
+            </a:r>
+          </a:p>
+        </p:txBody>
+      </p:sp>
+      <p:sp>
+        <p:nvSpPr>
+          <p:cNvPr id="34" name="Rounded Rectangle 33"/>
+          <p:cNvSpPr/>
+          <p:nvPr/>
+        </p:nvSpPr>
+        <p:spPr>
+          <a:xfrm>
+            <a:off x="1097280" y="4937760"/>
+            <a:ext cx="10515600" cy="658368"/>
+          </a:xfrm>
+          <a:prstGeom prst="roundRect">
+            <a:avLst/>
+          </a:prstGeom>
+          <a:solidFill>
+            <a:srgbClr val="FFFFFF"/>
+          </a:solidFill>
+          <a:ln w="12700">
+            <a:solidFill>
+              <a:srgbClr val="4A7A80"/>
+            </a:solidFill>
+          </a:ln>
+        </p:spPr>
+        <p:style>
+          <a:lnRef idx="1">
+            <a:schemeClr val="accent1"/>
+          </a:lnRef>
+          <a:fillRef idx="3">
+            <a:schemeClr val="accent1"/>
+          </a:fillRef>
+          <a:effectRef idx="2">
+            <a:schemeClr val="accent1"/>
+          </a:effectRef>
+          <a:fontRef idx="minor">
+            <a:schemeClr val="lt1"/>
+          </a:fontRef>
+        </p:style>
+        <p:txBody>
+          <a:bodyPr rtlCol="0" anchor="ctr"/>
+          <a:lstStyle/>
+          <a:p>
+            <a:pPr algn="ctr"/>
+          </a:p>
+        </p:txBody>
+      </p:sp>
+      <p:sp>
+        <p:nvSpPr>
+          <p:cNvPr id="35" name="TextBox 34"/>
+          <p:cNvSpPr txBox="1"/>
+          <p:nvPr/>
+        </p:nvSpPr>
+        <p:spPr>
+          <a:xfrm>
+            <a:off x="1234440" y="4992624"/>
+            <a:ext cx="10241280" cy="256032"/>
+          </a:xfrm>
+          <a:prstGeom prst="rect">
+            <a:avLst/>
+          </a:prstGeom>
+          <a:noFill/>
+        </p:spPr>
+        <p:txBody>
+          <a:bodyPr wrap="square">
+            <a:spAutoFit/>
+          </a:bodyPr>
+          <a:lstStyle/>
+          <a:p>
+            <a:pPr algn="l">
+              <a:defRPr sz="1200" b="1">
+                <a:solidFill>
+                  <a:srgbClr val="2A4A4E"/>
+                </a:solidFill>
+              </a:defRPr>
+            </a:pPr>
+            <a:r>
+              <a:t>Tapar secretos</a:t>
+            </a:r>
+          </a:p>
+        </p:txBody>
+      </p:sp>
+      <p:sp>
+        <p:nvSpPr>
+          <p:cNvPr id="36" name="TextBox 35"/>
+          <p:cNvSpPr txBox="1"/>
+          <p:nvPr/>
+        </p:nvSpPr>
+        <p:spPr>
+          <a:xfrm>
+            <a:off x="1234440" y="5248656"/>
+            <a:ext cx="10241280" cy="292608"/>
+          </a:xfrm>
+          <a:prstGeom prst="rect">
+            <a:avLst/>
+          </a:prstGeom>
+          <a:noFill/>
+        </p:spPr>
+        <p:txBody>
+          <a:bodyPr wrap="square">
+            <a:spAutoFit/>
+          </a:bodyPr>
+          <a:lstStyle/>
+          <a:p>
+            <a:pPr algn="l">
+              <a:defRPr sz="1000" b="0">
+                <a:solidFill>
+                  <a:srgbClr val="656D76"/>
+                </a:solidFill>
+              </a:defRPr>
+            </a:pPr>
+            <a:r>
+              <a:t>Pedir que oculten API keys y tokens antes de enviar.</a:t>
+            </a:r>
+          </a:p>
+        </p:txBody>
+      </p:sp>
+      <p:sp>
+        <p:nvSpPr>
+          <p:cNvPr id="37" name="Rounded Rectangle 36"/>
+          <p:cNvSpPr/>
+          <p:nvPr/>
+        </p:nvSpPr>
+        <p:spPr>
+          <a:xfrm>
+            <a:off x="685800" y="5166360"/>
+            <a:ext cx="10789920" cy="640080"/>
+          </a:xfrm>
+          <a:prstGeom prst="roundRect">
+            <a:avLst/>
+          </a:prstGeom>
+          <a:solidFill>
+            <a:srgbClr val="D4EDDA"/>
+          </a:solidFill>
+          <a:ln w="25400">
+            <a:solidFill>
+              <a:srgbClr val="1A7F37"/>
+            </a:solidFill>
+          </a:ln>
+        </p:spPr>
+        <p:style>
+          <a:lnRef idx="1">
+            <a:schemeClr val="accent1"/>
+          </a:lnRef>
+          <a:fillRef idx="3">
+            <a:schemeClr val="accent1"/>
+          </a:fillRef>
+          <a:effectRef idx="2">
+            <a:schemeClr val="accent1"/>
+          </a:effectRef>
+          <a:fontRef idx="minor">
+            <a:schemeClr val="lt1"/>
+          </a:fontRef>
+        </p:style>
+        <p:txBody>
+          <a:bodyPr rtlCol="0" anchor="ctr"/>
+          <a:lstStyle/>
+          <a:p>
+            <a:pPr algn="ctr"/>
+          </a:p>
+        </p:txBody>
+      </p:sp>
+      <p:sp>
+        <p:nvSpPr>
+          <p:cNvPr id="38" name="TextBox 37"/>
+          <p:cNvSpPr txBox="1"/>
+          <p:nvPr/>
+        </p:nvSpPr>
+        <p:spPr>
+          <a:xfrm>
+            <a:off x="868680" y="5303520"/>
+            <a:ext cx="10424160" cy="411480"/>
+          </a:xfrm>
+          <a:prstGeom prst="rect">
+            <a:avLst/>
+          </a:prstGeom>
+          <a:noFill/>
+        </p:spPr>
+        <p:txBody>
+          <a:bodyPr wrap="square">
+            <a:spAutoFit/>
+          </a:bodyPr>
+          <a:lstStyle/>
+          <a:p>
+            <a:pPr algn="l">
+              <a:defRPr sz="1200" b="1">
+                <a:solidFill>
+                  <a:srgbClr val="1A7F37"/>
+                </a:solidFill>
+              </a:defRPr>
+            </a:pPr>
+            <a:r>
+              <a:t>Las capturas complementan tabla y JSON — no las reemplazan. Guía: github-n8n.html</a:t>
             </a:r>
           </a:p>
         </p:txBody>
@@ -5028,7 +5478,7 @@
               </a:defRPr>
             </a:pPr>
             <a:r>
-              <a:t>Checklist · Pedido 3 — Contexto n8n</a:t>
+              <a:t>Checklist · Paso 3 — Capturas n8n</a:t>
             </a:r>
           </a:p>
         </p:txBody>
@@ -5063,7 +5513,7 @@
               </a:defRPr>
             </a:pPr>
             <a:r>
-              <a:t>Complemento a tabla y JSON</a:t>
+              <a:t>Por cada workflow activo</a:t>
             </a:r>
           </a:p>
         </p:txBody>
@@ -5141,7 +5591,7 @@
               </a:defRPr>
             </a:pPr>
             <a:r>
-              <a:t>C3 ✓</a:t>
+              <a:t>3 ✓</a:t>
             </a:r>
           </a:p>
         </p:txBody>
@@ -5211,7 +5661,7 @@
               </a:defRPr>
             </a:pPr>
             <a:r>
-              <a:t>URL de la instancia n8n recibida</a:t>
+              <a:t>Correo enviado con los 3 pedidos (tabla + JSON + capturas)</a:t>
             </a:r>
           </a:p>
         </p:txBody>
@@ -5281,7 +5731,7 @@
               </a:defRPr>
             </a:pPr>
             <a:r>
-              <a:t>Contacto admin n8n confirmado</a:t>
+              <a:t>Lista de capturas requeridas incluida en el correo</a:t>
             </a:r>
           </a:p>
         </p:txBody>
@@ -5351,7 +5801,7 @@
               </a:defRPr>
             </a:pPr>
             <a:r>
-              <a:t>Listado de webhooks sin autenticación (si existen)</a:t>
+              <a:t>Captura lista workflows recibida</a:t>
             </a:r>
           </a:p>
         </p:txBody>
@@ -5421,7 +5871,7 @@
               </a:defRPr>
             </a:pPr>
             <a:r>
-              <a:t>Workflows que validan usuario/sesión identificados</a:t>
+              <a:t>Captura canvas por workflow activo</a:t>
             </a:r>
           </a:p>
         </p:txBody>
@@ -5491,7 +5941,217 @@
               </a:defRPr>
             </a:pPr>
             <a:r>
-              <a:t>Decisión sobre backup automático vs manual documentada</a:t>
+              <a:t>Captura nodo Webhook por workflow (URL coincide con tabla)</a:t>
+            </a:r>
+          </a:p>
+        </p:txBody>
+      </p:sp>
+      <p:sp>
+        <p:nvSpPr>
+          <p:cNvPr id="17" name="TextBox 16"/>
+          <p:cNvSpPr txBox="1"/>
+          <p:nvPr/>
+        </p:nvSpPr>
+        <p:spPr>
+          <a:xfrm>
+            <a:off x="777240" y="3520440"/>
+            <a:ext cx="411480" cy="347472"/>
+          </a:xfrm>
+          <a:prstGeom prst="rect">
+            <a:avLst/>
+          </a:prstGeom>
+          <a:noFill/>
+        </p:spPr>
+        <p:txBody>
+          <a:bodyPr wrap="square">
+            <a:spAutoFit/>
+          </a:bodyPr>
+          <a:lstStyle/>
+          <a:p>
+            <a:pPr algn="l">
+              <a:defRPr sz="1800" b="1">
+                <a:solidFill>
+                  <a:srgbClr val="BF3F00"/>
+                </a:solidFill>
+              </a:defRPr>
+            </a:pPr>
+            <a:r>
+              <a:t>○</a:t>
+            </a:r>
+          </a:p>
+        </p:txBody>
+      </p:sp>
+      <p:sp>
+        <p:nvSpPr>
+          <p:cNvPr id="18" name="TextBox 17"/>
+          <p:cNvSpPr txBox="1"/>
+          <p:nvPr/>
+        </p:nvSpPr>
+        <p:spPr>
+          <a:xfrm>
+            <a:off x="1234440" y="3520440"/>
+            <a:ext cx="10332720" cy="347472"/>
+          </a:xfrm>
+          <a:prstGeom prst="rect">
+            <a:avLst/>
+          </a:prstGeom>
+          <a:noFill/>
+        </p:spPr>
+        <p:txBody>
+          <a:bodyPr wrap="square">
+            <a:spAutoFit/>
+          </a:bodyPr>
+          <a:lstStyle/>
+          <a:p>
+            <a:pPr algn="l">
+              <a:defRPr sz="1500" b="0">
+                <a:solidFill>
+                  <a:srgbClr val="1F2328"/>
+                </a:solidFill>
+              </a:defRPr>
+            </a:pPr>
+            <a:r>
+              <a:t>Capturas de validación auth recibidas o «sin auth» documentado</a:t>
+            </a:r>
+          </a:p>
+        </p:txBody>
+      </p:sp>
+      <p:sp>
+        <p:nvSpPr>
+          <p:cNvPr id="19" name="TextBox 18"/>
+          <p:cNvSpPr txBox="1"/>
+          <p:nvPr/>
+        </p:nvSpPr>
+        <p:spPr>
+          <a:xfrm>
+            <a:off x="777240" y="3959352"/>
+            <a:ext cx="411480" cy="347472"/>
+          </a:xfrm>
+          <a:prstGeom prst="rect">
+            <a:avLst/>
+          </a:prstGeom>
+          <a:noFill/>
+        </p:spPr>
+        <p:txBody>
+          <a:bodyPr wrap="square">
+            <a:spAutoFit/>
+          </a:bodyPr>
+          <a:lstStyle/>
+          <a:p>
+            <a:pPr algn="l">
+              <a:defRPr sz="1800" b="1">
+                <a:solidFill>
+                  <a:srgbClr val="BF3F00"/>
+                </a:solidFill>
+              </a:defRPr>
+            </a:pPr>
+            <a:r>
+              <a:t>○</a:t>
+            </a:r>
+          </a:p>
+        </p:txBody>
+      </p:sp>
+      <p:sp>
+        <p:nvSpPr>
+          <p:cNvPr id="20" name="TextBox 19"/>
+          <p:cNvSpPr txBox="1"/>
+          <p:nvPr/>
+        </p:nvSpPr>
+        <p:spPr>
+          <a:xfrm>
+            <a:off x="1234440" y="3959352"/>
+            <a:ext cx="10332720" cy="347472"/>
+          </a:xfrm>
+          <a:prstGeom prst="rect">
+            <a:avLst/>
+          </a:prstGeom>
+          <a:noFill/>
+        </p:spPr>
+        <p:txBody>
+          <a:bodyPr wrap="square">
+            <a:spAutoFit/>
+          </a:bodyPr>
+          <a:lstStyle/>
+          <a:p>
+            <a:pPr algn="l">
+              <a:defRPr sz="1500" b="0">
+                <a:solidFill>
+                  <a:srgbClr val="1F2328"/>
+                </a:solidFill>
+              </a:defRPr>
+            </a:pPr>
+            <a:r>
+              <a:t>Secretos tapados en todas las capturas</a:t>
+            </a:r>
+          </a:p>
+        </p:txBody>
+      </p:sp>
+      <p:sp>
+        <p:nvSpPr>
+          <p:cNvPr id="21" name="TextBox 20"/>
+          <p:cNvSpPr txBox="1"/>
+          <p:nvPr/>
+        </p:nvSpPr>
+        <p:spPr>
+          <a:xfrm>
+            <a:off x="777240" y="4398264"/>
+            <a:ext cx="411480" cy="347472"/>
+          </a:xfrm>
+          <a:prstGeom prst="rect">
+            <a:avLst/>
+          </a:prstGeom>
+          <a:noFill/>
+        </p:spPr>
+        <p:txBody>
+          <a:bodyPr wrap="square">
+            <a:spAutoFit/>
+          </a:bodyPr>
+          <a:lstStyle/>
+          <a:p>
+            <a:pPr algn="l">
+              <a:defRPr sz="1800" b="1">
+                <a:solidFill>
+                  <a:srgbClr val="BF3F00"/>
+                </a:solidFill>
+              </a:defRPr>
+            </a:pPr>
+            <a:r>
+              <a:t>○</a:t>
+            </a:r>
+          </a:p>
+        </p:txBody>
+      </p:sp>
+      <p:sp>
+        <p:nvSpPr>
+          <p:cNvPr id="22" name="TextBox 21"/>
+          <p:cNvSpPr txBox="1"/>
+          <p:nvPr/>
+        </p:nvSpPr>
+        <p:spPr>
+          <a:xfrm>
+            <a:off x="1234440" y="4398264"/>
+            <a:ext cx="10332720" cy="347472"/>
+          </a:xfrm>
+          <a:prstGeom prst="rect">
+            <a:avLst/>
+          </a:prstGeom>
+          <a:noFill/>
+        </p:spPr>
+        <p:txBody>
+          <a:bodyPr wrap="square">
+            <a:spAutoFit/>
+          </a:bodyPr>
+          <a:lstStyle/>
+          <a:p>
+            <a:pPr algn="l">
+              <a:defRPr sz="1500" b="0">
+                <a:solidFill>
+                  <a:srgbClr val="1F2328"/>
+                </a:solidFill>
+              </a:defRPr>
+            </a:pPr>
+            <a:r>
+              <a:t>Entregables organizados en carpeta por workflow</a:t>
             </a:r>
           </a:p>
         </p:txBody>
@@ -5595,7 +6255,7 @@
               </a:defRPr>
             </a:pPr>
             <a:r>
-              <a:t>Qué NO pedir (o pedir con cuidado)</a:t>
+              <a:t>Paso 3 · Contexto complementario</a:t>
             </a:r>
           </a:p>
         </p:txBody>
@@ -5630,7 +6290,7 @@
               </a:defRPr>
             </a:pPr>
             <a:r>
-              <a:t>Evitar riesgos de seguridad</a:t>
+              <a:t>Además de tabla, JSON y capturas</a:t>
             </a:r>
           </a:p>
         </p:txBody>
@@ -5643,19 +6303,17 @@
         </p:nvSpPr>
         <p:spPr>
           <a:xfrm>
-            <a:off x="685800" y="1325880"/>
-            <a:ext cx="4846320" cy="594360"/>
+            <a:off x="9875520" y="256032"/>
+            <a:ext cx="1828800" cy="457200"/>
           </a:xfrm>
           <a:prstGeom prst="roundRect">
             <a:avLst/>
           </a:prstGeom>
           <a:solidFill>
-            <a:srgbClr val="FFE8D6"/>
+            <a:srgbClr val="2A4A4E"/>
           </a:solidFill>
-          <a:ln w="12700">
-            <a:solidFill>
-              <a:srgbClr val="BF3F00"/>
-            </a:solidFill>
+          <a:ln>
+            <a:noFill/>
           </a:ln>
         </p:spPr>
         <p:style>
@@ -5688,29 +6346,29 @@
         </p:nvSpPr>
         <p:spPr>
           <a:xfrm>
-            <a:off x="822960" y="1490472"/>
-            <a:ext cx="4572000" cy="320040"/>
-          </a:xfrm>
-          <a:prstGeom prst="rect">
-            <a:avLst/>
-          </a:prstGeom>
-          <a:noFill/>
-        </p:spPr>
-        <p:txBody>
-          <a:bodyPr wrap="square">
-            <a:spAutoFit/>
-          </a:bodyPr>
-          <a:lstStyle/>
-          <a:p>
-            <a:pPr algn="l">
+            <a:off x="9875520" y="329184"/>
+            <a:ext cx="1828800" cy="320040"/>
+          </a:xfrm>
+          <a:prstGeom prst="rect">
+            <a:avLst/>
+          </a:prstGeom>
+          <a:noFill/>
+        </p:spPr>
+        <p:txBody>
+          <a:bodyPr wrap="square">
+            <a:spAutoFit/>
+          </a:bodyPr>
+          <a:lstStyle/>
+          <a:p>
+            <a:pPr algn="ctr">
               <a:defRPr sz="1100" b="1">
                 <a:solidFill>
-                  <a:srgbClr val="BF3F00"/>
-                </a:solidFill>
-              </a:defRPr>
-            </a:pPr>
-            <a:r>
-              <a:t>✗  Contraseñas / API keys por correo</a:t>
+                  <a:srgbClr val="FFFFFF"/>
+                </a:solidFill>
+              </a:defRPr>
+            </a:pPr>
+            <a:r>
+              <a:t>+</a:t>
             </a:r>
           </a:p>
         </p:txBody>
@@ -5723,19 +6381,17 @@
         </p:nvSpPr>
         <p:spPr>
           <a:xfrm>
-            <a:off x="5760720" y="1325880"/>
-            <a:ext cx="5715000" cy="594360"/>
+            <a:off x="685800" y="1280160"/>
+            <a:ext cx="2194560" cy="640080"/>
           </a:xfrm>
           <a:prstGeom prst="roundRect">
             <a:avLst/>
           </a:prstGeom>
           <a:solidFill>
-            <a:srgbClr val="D4EDDA"/>
+            <a:srgbClr val="4A7A80"/>
           </a:solidFill>
-          <a:ln w="12700">
-            <a:solidFill>
-              <a:srgbClr val="1A7F37"/>
-            </a:solidFill>
+          <a:ln>
+            <a:noFill/>
           </a:ln>
         </p:spPr>
         <p:style>
@@ -5768,29 +6424,29 @@
         </p:nvSpPr>
         <p:spPr>
           <a:xfrm>
-            <a:off x="5897880" y="1435608"/>
-            <a:ext cx="5440680" cy="411480"/>
-          </a:xfrm>
-          <a:prstGeom prst="rect">
-            <a:avLst/>
-          </a:prstGeom>
-          <a:noFill/>
-        </p:spPr>
-        <p:txBody>
-          <a:bodyPr wrap="square">
-            <a:spAutoFit/>
-          </a:bodyPr>
-          <a:lstStyle/>
-          <a:p>
-            <a:pPr algn="l">
-              <a:defRPr sz="1000" b="0">
-                <a:solidFill>
-                  <a:srgbClr val="1A7F37"/>
-                </a:solidFill>
-              </a:defRPr>
-            </a:pPr>
-            <a:r>
-              <a:t>✓  Pedir solo tipo de auth y nombre de credencial en n8n</a:t>
+            <a:off x="685800" y="1481328"/>
+            <a:ext cx="2194560" cy="320040"/>
+          </a:xfrm>
+          <a:prstGeom prst="rect">
+            <a:avLst/>
+          </a:prstGeom>
+          <a:noFill/>
+        </p:spPr>
+        <p:txBody>
+          <a:bodyPr wrap="square">
+            <a:spAutoFit/>
+          </a:bodyPr>
+          <a:lstStyle/>
+          <a:p>
+            <a:pPr algn="ctr">
+              <a:defRPr sz="1000" b="1">
+                <a:solidFill>
+                  <a:srgbClr val="FFFFFF"/>
+                </a:solidFill>
+              </a:defRPr>
+            </a:pPr>
+            <a:r>
+              <a:t>URL instancia n8n</a:t>
             </a:r>
           </a:p>
         </p:txBody>
@@ -5803,18 +6459,18 @@
         </p:nvSpPr>
         <p:spPr>
           <a:xfrm>
-            <a:off x="685800" y="2039112"/>
-            <a:ext cx="4846320" cy="594360"/>
+            <a:off x="3063240" y="1280160"/>
+            <a:ext cx="8412480" cy="640080"/>
           </a:xfrm>
           <a:prstGeom prst="roundRect">
             <a:avLst/>
           </a:prstGeom>
           <a:solidFill>
-            <a:srgbClr val="FFE8D6"/>
+            <a:srgbClr val="FFFFFF"/>
           </a:solidFill>
           <a:ln w="12700">
             <a:solidFill>
-              <a:srgbClr val="BF3F00"/>
+              <a:srgbClr val="656D76"/>
             </a:solidFill>
           </a:ln>
         </p:spPr>
@@ -5848,29 +6504,29 @@
         </p:nvSpPr>
         <p:spPr>
           <a:xfrm>
-            <a:off x="822960" y="2203704"/>
-            <a:ext cx="4572000" cy="320040"/>
-          </a:xfrm>
-          <a:prstGeom prst="rect">
-            <a:avLst/>
-          </a:prstGeom>
-          <a:noFill/>
-        </p:spPr>
-        <p:txBody>
-          <a:bodyPr wrap="square">
-            <a:spAutoFit/>
-          </a:bodyPr>
-          <a:lstStyle/>
-          <a:p>
-            <a:pPr algn="l">
-              <a:defRPr sz="1100" b="1">
-                <a:solidFill>
-                  <a:srgbClr val="BF3F00"/>
-                </a:solidFill>
-              </a:defRPr>
-            </a:pPr>
-            <a:r>
-              <a:t>✗  Solo JSON sin tabla</a:t>
+            <a:off x="3200400" y="1463040"/>
+            <a:ext cx="8138160" cy="320040"/>
+          </a:xfrm>
+          <a:prstGeom prst="rect">
+            <a:avLst/>
+          </a:prstGeom>
+          <a:noFill/>
+        </p:spPr>
+        <p:txBody>
+          <a:bodyPr wrap="square">
+            <a:spAutoFit/>
+          </a:bodyPr>
+          <a:lstStyle/>
+          <a:p>
+            <a:pPr algn="l">
+              <a:defRPr sz="1200" b="0">
+                <a:solidFill>
+                  <a:srgbClr val="1F2328"/>
+                </a:solidFill>
+              </a:defRPr>
+            </a:pPr>
+            <a:r>
+              <a:t>Ej. n8n.empresa.cl — dónde administran.</a:t>
             </a:r>
           </a:p>
         </p:txBody>
@@ -5883,19 +6539,17 @@
         </p:nvSpPr>
         <p:spPr>
           <a:xfrm>
-            <a:off x="5760720" y="2039112"/>
-            <a:ext cx="5715000" cy="594360"/>
+            <a:off x="685800" y="2029968"/>
+            <a:ext cx="2194560" cy="640080"/>
           </a:xfrm>
           <a:prstGeom prst="roundRect">
             <a:avLst/>
           </a:prstGeom>
           <a:solidFill>
-            <a:srgbClr val="D4EDDA"/>
+            <a:srgbClr val="4A7A80"/>
           </a:solidFill>
-          <a:ln w="12700">
-            <a:solidFill>
-              <a:srgbClr val="1A7F37"/>
-            </a:solidFill>
+          <a:ln>
+            <a:noFill/>
           </a:ln>
         </p:spPr>
         <p:style>
@@ -5928,29 +6582,29 @@
         </p:nvSpPr>
         <p:spPr>
           <a:xfrm>
-            <a:off x="5897880" y="2148840"/>
-            <a:ext cx="5440680" cy="411480"/>
-          </a:xfrm>
-          <a:prstGeom prst="rect">
-            <a:avLst/>
-          </a:prstGeom>
-          <a:noFill/>
-        </p:spPr>
-        <p:txBody>
-          <a:bodyPr wrap="square">
-            <a:spAutoFit/>
-          </a:bodyPr>
-          <a:lstStyle/>
-          <a:p>
-            <a:pPr algn="l">
-              <a:defRPr sz="1000" b="0">
-                <a:solidFill>
-                  <a:srgbClr val="1A7F37"/>
-                </a:solidFill>
-              </a:defRPr>
-            </a:pPr>
-            <a:r>
-              <a:t>✓  Pedir AMBOS: inventario (tabla) + backup (JSON)</a:t>
+            <a:off x="685800" y="2231136"/>
+            <a:ext cx="2194560" cy="320040"/>
+          </a:xfrm>
+          <a:prstGeom prst="rect">
+            <a:avLst/>
+          </a:prstGeom>
+          <a:noFill/>
+        </p:spPr>
+        <p:txBody>
+          <a:bodyPr wrap="square">
+            <a:spAutoFit/>
+          </a:bodyPr>
+          <a:lstStyle/>
+          <a:p>
+            <a:pPr algn="ctr">
+              <a:defRPr sz="1000" b="1">
+                <a:solidFill>
+                  <a:srgbClr val="FFFFFF"/>
+                </a:solidFill>
+              </a:defRPr>
+            </a:pPr>
+            <a:r>
+              <a:t>Admin / contacto</a:t>
             </a:r>
           </a:p>
         </p:txBody>
@@ -5963,18 +6617,18 @@
         </p:nvSpPr>
         <p:spPr>
           <a:xfrm>
-            <a:off x="685800" y="2752344"/>
-            <a:ext cx="4846320" cy="594360"/>
+            <a:off x="3063240" y="2029968"/>
+            <a:ext cx="8412480" cy="640080"/>
           </a:xfrm>
           <a:prstGeom prst="roundRect">
             <a:avLst/>
           </a:prstGeom>
           <a:solidFill>
-            <a:srgbClr val="FFE8D6"/>
+            <a:srgbClr val="FFFFFF"/>
           </a:solidFill>
           <a:ln w="12700">
             <a:solidFill>
-              <a:srgbClr val="BF3F00"/>
+              <a:srgbClr val="656D76"/>
             </a:solidFill>
           </a:ln>
         </p:spPr>
@@ -6008,29 +6662,29 @@
         </p:nvSpPr>
         <p:spPr>
           <a:xfrm>
-            <a:off x="822960" y="2916936"/>
-            <a:ext cx="4572000" cy="320040"/>
-          </a:xfrm>
-          <a:prstGeom prst="rect">
-            <a:avLst/>
-          </a:prstGeom>
-          <a:noFill/>
-        </p:spPr>
-        <p:txBody>
-          <a:bodyPr wrap="square">
-            <a:spAutoFit/>
-          </a:bodyPr>
-          <a:lstStyle/>
-          <a:p>
-            <a:pPr algn="l">
-              <a:defRPr sz="1100" b="1">
-                <a:solidFill>
-                  <a:srgbClr val="BF3F00"/>
-                </a:solidFill>
-              </a:defRPr>
-            </a:pPr>
-            <a:r>
-              <a:t>✗  Acceso admin n8n hoy</a:t>
+            <a:off x="3200400" y="2212848"/>
+            <a:ext cx="8138160" cy="320040"/>
+          </a:xfrm>
+          <a:prstGeom prst="rect">
+            <a:avLst/>
+          </a:prstGeom>
+          <a:noFill/>
+        </p:spPr>
+        <p:txBody>
+          <a:bodyPr wrap="square">
+            <a:spAutoFit/>
+          </a:bodyPr>
+          <a:lstStyle/>
+          <a:p>
+            <a:pPr algn="l">
+              <a:defRPr sz="1200" b="0">
+                <a:solidFill>
+                  <a:srgbClr val="1F2328"/>
+                </a:solidFill>
+              </a:defRPr>
+            </a:pPr>
+            <a:r>
+              <a:t>Quién tiene acceso admin para cambios futuros.</a:t>
             </a:r>
           </a:p>
         </p:txBody>
@@ -6043,19 +6697,17 @@
         </p:nvSpPr>
         <p:spPr>
           <a:xfrm>
-            <a:off x="5760720" y="2752344"/>
-            <a:ext cx="5715000" cy="594360"/>
+            <a:off x="685800" y="2779776"/>
+            <a:ext cx="2194560" cy="640080"/>
           </a:xfrm>
           <a:prstGeom prst="roundRect">
             <a:avLst/>
           </a:prstGeom>
           <a:solidFill>
-            <a:srgbClr val="D4EDDA"/>
+            <a:srgbClr val="4A7A80"/>
           </a:solidFill>
-          <a:ln w="12700">
-            <a:solidFill>
-              <a:srgbClr val="1A7F37"/>
-            </a:solidFill>
+          <a:ln>
+            <a:noFill/>
           </a:ln>
         </p:spPr>
         <p:style>
@@ -6088,29 +6740,29 @@
         </p:nvSpPr>
         <p:spPr>
           <a:xfrm>
-            <a:off x="5897880" y="2862072"/>
-            <a:ext cx="5440680" cy="411480"/>
-          </a:xfrm>
-          <a:prstGeom prst="rect">
-            <a:avLst/>
-          </a:prstGeom>
-          <a:noFill/>
-        </p:spPr>
-        <p:txBody>
-          <a:bodyPr wrap="square">
-            <a:spAutoFit/>
-          </a:bodyPr>
-          <a:lstStyle/>
-          <a:p>
-            <a:pPr algn="l">
-              <a:defRPr sz="1000" b="0">
-                <a:solidFill>
-                  <a:srgbClr val="1A7F37"/>
-                </a:solidFill>
-              </a:defRPr>
-            </a:pPr>
-            <a:r>
-              <a:t>✓  Solo listado + exports; admin puede ser después</a:t>
+            <a:off x="685800" y="2980944"/>
+            <a:ext cx="2194560" cy="320040"/>
+          </a:xfrm>
+          <a:prstGeom prst="rect">
+            <a:avLst/>
+          </a:prstGeom>
+          <a:noFill/>
+        </p:spPr>
+        <p:txBody>
+          <a:bodyPr wrap="square">
+            <a:spAutoFit/>
+          </a:bodyPr>
+          <a:lstStyle/>
+          <a:p>
+            <a:pPr algn="ctr">
+              <a:defRPr sz="1000" b="1">
+                <a:solidFill>
+                  <a:srgbClr val="FFFFFF"/>
+                </a:solidFill>
+              </a:defRPr>
+            </a:pPr>
+            <a:r>
+              <a:t>Webhooks sin auth</a:t>
             </a:r>
           </a:p>
         </p:txBody>
@@ -6123,18 +6775,18 @@
         </p:nvSpPr>
         <p:spPr>
           <a:xfrm>
-            <a:off x="685800" y="3465576"/>
-            <a:ext cx="4846320" cy="594360"/>
+            <a:off x="3063240" y="2779776"/>
+            <a:ext cx="8412480" cy="640080"/>
           </a:xfrm>
           <a:prstGeom prst="roundRect">
             <a:avLst/>
           </a:prstGeom>
           <a:solidFill>
-            <a:srgbClr val="FFE8D6"/>
+            <a:srgbClr val="FFFFFF"/>
           </a:solidFill>
           <a:ln w="12700">
             <a:solidFill>
-              <a:srgbClr val="BF3F00"/>
+              <a:srgbClr val="656D76"/>
             </a:solidFill>
           </a:ln>
         </p:spPr>
@@ -6168,29 +6820,29 @@
         </p:nvSpPr>
         <p:spPr>
           <a:xfrm>
-            <a:off x="822960" y="3630168"/>
-            <a:ext cx="4572000" cy="320040"/>
-          </a:xfrm>
-          <a:prstGeom prst="rect">
-            <a:avLst/>
-          </a:prstGeom>
-          <a:noFill/>
-        </p:spPr>
-        <p:txBody>
-          <a:bodyPr wrap="square">
-            <a:spAutoFit/>
-          </a:bodyPr>
-          <a:lstStyle/>
-          <a:p>
-            <a:pPr algn="l">
-              <a:defRPr sz="1100" b="1">
-                <a:solidFill>
-                  <a:srgbClr val="BF3F00"/>
-                </a:solidFill>
-              </a:defRPr>
-            </a:pPr>
-            <a:r>
-              <a:t>✗  Export con secretos embebidos</a:t>
+            <a:off x="3200400" y="2962656"/>
+            <a:ext cx="8138160" cy="320040"/>
+          </a:xfrm>
+          <a:prstGeom prst="rect">
+            <a:avLst/>
+          </a:prstGeom>
+          <a:noFill/>
+        </p:spPr>
+        <p:txBody>
+          <a:bodyPr wrap="square">
+            <a:spAutoFit/>
+          </a:bodyPr>
+          <a:lstStyle/>
+          <a:p>
+            <a:pPr algn="l">
+              <a:defRPr sz="1200" b="0">
+                <a:solidFill>
+                  <a:srgbClr val="1F2328"/>
+                </a:solidFill>
+              </a:defRPr>
+            </a:pPr>
+            <a:r>
+              <a:t>¿Algún endpoint público sin validación? — riesgo a documentar.</a:t>
             </a:r>
           </a:p>
         </p:txBody>
@@ -6203,19 +6855,17 @@
         </p:nvSpPr>
         <p:spPr>
           <a:xfrm>
-            <a:off x="5760720" y="3465576"/>
-            <a:ext cx="5715000" cy="594360"/>
+            <a:off x="685800" y="3529584"/>
+            <a:ext cx="2194560" cy="640080"/>
           </a:xfrm>
           <a:prstGeom prst="roundRect">
             <a:avLst/>
           </a:prstGeom>
           <a:solidFill>
-            <a:srgbClr val="D4EDDA"/>
+            <a:srgbClr val="4A7A80"/>
           </a:solidFill>
-          <a:ln w="12700">
-            <a:solidFill>
-              <a:srgbClr val="1A7F37"/>
-            </a:solidFill>
+          <a:ln>
+            <a:noFill/>
           </a:ln>
         </p:spPr>
         <p:style>
@@ -6248,29 +6898,267 @@
         </p:nvSpPr>
         <p:spPr>
           <a:xfrm>
-            <a:off x="5897880" y="3575304"/>
-            <a:ext cx="5440680" cy="411480"/>
-          </a:xfrm>
-          <a:prstGeom prst="rect">
-            <a:avLst/>
-          </a:prstGeom>
-          <a:noFill/>
-        </p:spPr>
-        <p:txBody>
-          <a:bodyPr wrap="square">
-            <a:spAutoFit/>
-          </a:bodyPr>
-          <a:lstStyle/>
-          <a:p>
-            <a:pPr algn="l">
-              <a:defRPr sz="1000" b="0">
-                <a:solidFill>
-                  <a:srgbClr val="1A7F37"/>
-                </a:solidFill>
-              </a:defRPr>
-            </a:pPr>
-            <a:r>
-              <a:t>✓  Export estándar; credenciales documentadas aparte en n8n</a:t>
+            <a:off x="685800" y="3730752"/>
+            <a:ext cx="2194560" cy="320040"/>
+          </a:xfrm>
+          <a:prstGeom prst="rect">
+            <a:avLst/>
+          </a:prstGeom>
+          <a:noFill/>
+        </p:spPr>
+        <p:txBody>
+          <a:bodyPr wrap="square">
+            <a:spAutoFit/>
+          </a:bodyPr>
+          <a:lstStyle/>
+          <a:p>
+            <a:pPr algn="ctr">
+              <a:defRPr sz="1000" b="1">
+                <a:solidFill>
+                  <a:srgbClr val="FFFFFF"/>
+                </a:solidFill>
+              </a:defRPr>
+            </a:pPr>
+            <a:r>
+              <a:t>Validación de usuario</a:t>
+            </a:r>
+          </a:p>
+        </p:txBody>
+      </p:sp>
+      <p:sp>
+        <p:nvSpPr>
+          <p:cNvPr id="21" name="Rounded Rectangle 20"/>
+          <p:cNvSpPr/>
+          <p:nvPr/>
+        </p:nvSpPr>
+        <p:spPr>
+          <a:xfrm>
+            <a:off x="3063240" y="3529584"/>
+            <a:ext cx="8412480" cy="640080"/>
+          </a:xfrm>
+          <a:prstGeom prst="roundRect">
+            <a:avLst/>
+          </a:prstGeom>
+          <a:solidFill>
+            <a:srgbClr val="FFFFFF"/>
+          </a:solidFill>
+          <a:ln w="12700">
+            <a:solidFill>
+              <a:srgbClr val="656D76"/>
+            </a:solidFill>
+          </a:ln>
+        </p:spPr>
+        <p:style>
+          <a:lnRef idx="1">
+            <a:schemeClr val="accent1"/>
+          </a:lnRef>
+          <a:fillRef idx="3">
+            <a:schemeClr val="accent1"/>
+          </a:fillRef>
+          <a:effectRef idx="2">
+            <a:schemeClr val="accent1"/>
+          </a:effectRef>
+          <a:fontRef idx="minor">
+            <a:schemeClr val="lt1"/>
+          </a:fontRef>
+        </p:style>
+        <p:txBody>
+          <a:bodyPr rtlCol="0" anchor="ctr"/>
+          <a:lstStyle/>
+          <a:p>
+            <a:pPr algn="ctr"/>
+          </a:p>
+        </p:txBody>
+      </p:sp>
+      <p:sp>
+        <p:nvSpPr>
+          <p:cNvPr id="22" name="TextBox 21"/>
+          <p:cNvSpPr txBox="1"/>
+          <p:nvPr/>
+        </p:nvSpPr>
+        <p:spPr>
+          <a:xfrm>
+            <a:off x="3200400" y="3712464"/>
+            <a:ext cx="8138160" cy="320040"/>
+          </a:xfrm>
+          <a:prstGeom prst="rect">
+            <a:avLst/>
+          </a:prstGeom>
+          <a:noFill/>
+        </p:spPr>
+        <p:txBody>
+          <a:bodyPr wrap="square">
+            <a:spAutoFit/>
+          </a:bodyPr>
+          <a:lstStyle/>
+          <a:p>
+            <a:pPr algn="l">
+              <a:defRPr sz="1200" b="0">
+                <a:solidFill>
+                  <a:srgbClr val="1F2328"/>
+                </a:solidFill>
+              </a:defRPr>
+            </a:pPr>
+            <a:r>
+              <a:t>¿Algún workflow valida sesión/token de usuario? (clave para D5).</a:t>
+            </a:r>
+          </a:p>
+        </p:txBody>
+      </p:sp>
+      <p:sp>
+        <p:nvSpPr>
+          <p:cNvPr id="23" name="Rounded Rectangle 22"/>
+          <p:cNvSpPr/>
+          <p:nvPr/>
+        </p:nvSpPr>
+        <p:spPr>
+          <a:xfrm>
+            <a:off x="685800" y="4279392"/>
+            <a:ext cx="2194560" cy="640080"/>
+          </a:xfrm>
+          <a:prstGeom prst="roundRect">
+            <a:avLst/>
+          </a:prstGeom>
+          <a:solidFill>
+            <a:srgbClr val="4A7A80"/>
+          </a:solidFill>
+          <a:ln>
+            <a:noFill/>
+          </a:ln>
+        </p:spPr>
+        <p:style>
+          <a:lnRef idx="1">
+            <a:schemeClr val="accent1"/>
+          </a:lnRef>
+          <a:fillRef idx="3">
+            <a:schemeClr val="accent1"/>
+          </a:fillRef>
+          <a:effectRef idx="2">
+            <a:schemeClr val="accent1"/>
+          </a:effectRef>
+          <a:fontRef idx="minor">
+            <a:schemeClr val="lt1"/>
+          </a:fontRef>
+        </p:style>
+        <p:txBody>
+          <a:bodyPr rtlCol="0" anchor="ctr"/>
+          <a:lstStyle/>
+          <a:p>
+            <a:pPr algn="ctr"/>
+          </a:p>
+        </p:txBody>
+      </p:sp>
+      <p:sp>
+        <p:nvSpPr>
+          <p:cNvPr id="24" name="TextBox 23"/>
+          <p:cNvSpPr txBox="1"/>
+          <p:nvPr/>
+        </p:nvSpPr>
+        <p:spPr>
+          <a:xfrm>
+            <a:off x="685800" y="4480560"/>
+            <a:ext cx="2194560" cy="320040"/>
+          </a:xfrm>
+          <a:prstGeom prst="rect">
+            <a:avLst/>
+          </a:prstGeom>
+          <a:noFill/>
+        </p:spPr>
+        <p:txBody>
+          <a:bodyPr wrap="square">
+            <a:spAutoFit/>
+          </a:bodyPr>
+          <a:lstStyle/>
+          <a:p>
+            <a:pPr algn="ctr">
+              <a:defRPr sz="1000" b="1">
+                <a:solidFill>
+                  <a:srgbClr val="FFFFFF"/>
+                </a:solidFill>
+              </a:defRPr>
+            </a:pPr>
+            <a:r>
+              <a:t>Backup automático</a:t>
+            </a:r>
+          </a:p>
+        </p:txBody>
+      </p:sp>
+      <p:sp>
+        <p:nvSpPr>
+          <p:cNvPr id="25" name="Rounded Rectangle 24"/>
+          <p:cNvSpPr/>
+          <p:nvPr/>
+        </p:nvSpPr>
+        <p:spPr>
+          <a:xfrm>
+            <a:off x="3063240" y="4279392"/>
+            <a:ext cx="8412480" cy="640080"/>
+          </a:xfrm>
+          <a:prstGeom prst="roundRect">
+            <a:avLst/>
+          </a:prstGeom>
+          <a:solidFill>
+            <a:srgbClr val="FFFFFF"/>
+          </a:solidFill>
+          <a:ln w="12700">
+            <a:solidFill>
+              <a:srgbClr val="656D76"/>
+            </a:solidFill>
+          </a:ln>
+        </p:spPr>
+        <p:style>
+          <a:lnRef idx="1">
+            <a:schemeClr val="accent1"/>
+          </a:lnRef>
+          <a:fillRef idx="3">
+            <a:schemeClr val="accent1"/>
+          </a:fillRef>
+          <a:effectRef idx="2">
+            <a:schemeClr val="accent1"/>
+          </a:effectRef>
+          <a:fontRef idx="minor">
+            <a:schemeClr val="lt1"/>
+          </a:fontRef>
+        </p:style>
+        <p:txBody>
+          <a:bodyPr rtlCol="0" anchor="ctr"/>
+          <a:lstStyle/>
+          <a:p>
+            <a:pPr algn="ctr"/>
+          </a:p>
+        </p:txBody>
+      </p:sp>
+      <p:sp>
+        <p:nvSpPr>
+          <p:cNvPr id="26" name="TextBox 25"/>
+          <p:cNvSpPr txBox="1"/>
+          <p:nvPr/>
+        </p:nvSpPr>
+        <p:spPr>
+          <a:xfrm>
+            <a:off x="3200400" y="4462272"/>
+            <a:ext cx="8138160" cy="320040"/>
+          </a:xfrm>
+          <a:prstGeom prst="rect">
+            <a:avLst/>
+          </a:prstGeom>
+          <a:noFill/>
+        </p:spPr>
+        <p:txBody>
+          <a:bodyPr wrap="square">
+            <a:spAutoFit/>
+          </a:bodyPr>
+          <a:lstStyle/>
+          <a:p>
+            <a:pPr algn="l">
+              <a:defRPr sz="1200" b="0">
+                <a:solidFill>
+                  <a:srgbClr val="1F2328"/>
+                </a:solidFill>
+              </a:defRPr>
+            </a:pPr>
+            <a:r>
+              <a:t>¿Existe sync a GitHub o hay que configurarlo después del repo?</a:t>
             </a:r>
           </a:p>
         </p:txBody>
@@ -6374,7 +7262,7 @@
               </a:defRPr>
             </a:pPr>
             <a:r>
-              <a:t>Texto listo para enviar al equipo n8n</a:t>
+              <a:t>Checklist · Contexto n8n</a:t>
             </a:r>
           </a:p>
         </p:txBody>
@@ -6409,7 +7297,7 @@
               </a:defRPr>
             </a:pPr>
             <a:r>
-              <a:t>Copiar y pegar en correo</a:t>
+              <a:t>Complemento al Paso 3</a:t>
             </a:r>
           </a:p>
         </p:txBody>
@@ -6422,19 +7310,17 @@
         </p:nvSpPr>
         <p:spPr>
           <a:xfrm>
-            <a:off x="685800" y="1234440"/>
-            <a:ext cx="10789920" cy="5029200"/>
+            <a:off x="9875520" y="256032"/>
+            <a:ext cx="1828800" cy="457200"/>
           </a:xfrm>
           <a:prstGeom prst="roundRect">
             <a:avLst/>
           </a:prstGeom>
           <a:solidFill>
-            <a:srgbClr val="FFFFFF"/>
+            <a:srgbClr val="2A4A4E"/>
           </a:solidFill>
-          <a:ln w="25400">
-            <a:solidFill>
-              <a:srgbClr val="4A7A80"/>
-            </a:solidFill>
+          <a:ln>
+            <a:noFill/>
           </a:ln>
         </p:spPr>
         <p:style>
@@ -6467,77 +7353,379 @@
         </p:nvSpPr>
         <p:spPr>
           <a:xfrm>
-            <a:off x="868680" y="1371600"/>
-            <a:ext cx="10424160" cy="4754880"/>
-          </a:xfrm>
-          <a:prstGeom prst="rect">
-            <a:avLst/>
-          </a:prstGeom>
-          <a:noFill/>
-        </p:spPr>
-        <p:txBody>
-          <a:bodyPr wrap="square">
-            <a:spAutoFit/>
-          </a:bodyPr>
-          <a:lstStyle/>
-          <a:p>
-            <a:pPr algn="l">
-              <a:defRPr sz="1100" b="0">
+            <a:off x="9875520" y="329184"/>
+            <a:ext cx="1828800" cy="320040"/>
+          </a:xfrm>
+          <a:prstGeom prst="rect">
+            <a:avLst/>
+          </a:prstGeom>
+          <a:noFill/>
+        </p:spPr>
+        <p:txBody>
+          <a:bodyPr wrap="square">
+            <a:spAutoFit/>
+          </a:bodyPr>
+          <a:lstStyle/>
+          <a:p>
+            <a:pPr algn="ctr">
+              <a:defRPr sz="1100" b="1">
+                <a:solidFill>
+                  <a:srgbClr val="FFFFFF"/>
+                </a:solidFill>
+              </a:defRPr>
+            </a:pPr>
+            <a:r>
+              <a:t>+ ✓</a:t>
+            </a:r>
+          </a:p>
+        </p:txBody>
+      </p:sp>
+      <p:sp>
+        <p:nvSpPr>
+          <p:cNvPr id="7" name="TextBox 6"/>
+          <p:cNvSpPr txBox="1"/>
+          <p:nvPr/>
+        </p:nvSpPr>
+        <p:spPr>
+          <a:xfrm>
+            <a:off x="777240" y="1325880"/>
+            <a:ext cx="411480" cy="347472"/>
+          </a:xfrm>
+          <a:prstGeom prst="rect">
+            <a:avLst/>
+          </a:prstGeom>
+          <a:noFill/>
+        </p:spPr>
+        <p:txBody>
+          <a:bodyPr wrap="square">
+            <a:spAutoFit/>
+          </a:bodyPr>
+          <a:lstStyle/>
+          <a:p>
+            <a:pPr algn="l">
+              <a:defRPr sz="1800" b="1">
+                <a:solidFill>
+                  <a:srgbClr val="BF3F00"/>
+                </a:solidFill>
+              </a:defRPr>
+            </a:pPr>
+            <a:r>
+              <a:t>○</a:t>
+            </a:r>
+          </a:p>
+        </p:txBody>
+      </p:sp>
+      <p:sp>
+        <p:nvSpPr>
+          <p:cNvPr id="8" name="TextBox 7"/>
+          <p:cNvSpPr txBox="1"/>
+          <p:nvPr/>
+        </p:nvSpPr>
+        <p:spPr>
+          <a:xfrm>
+            <a:off x="1234440" y="1325880"/>
+            <a:ext cx="10332720" cy="347472"/>
+          </a:xfrm>
+          <a:prstGeom prst="rect">
+            <a:avLst/>
+          </a:prstGeom>
+          <a:noFill/>
+        </p:spPr>
+        <p:txBody>
+          <a:bodyPr wrap="square">
+            <a:spAutoFit/>
+          </a:bodyPr>
+          <a:lstStyle/>
+          <a:p>
+            <a:pPr algn="l">
+              <a:defRPr sz="1500" b="0">
                 <a:solidFill>
                   <a:srgbClr val="1F2328"/>
                 </a:solidFill>
               </a:defRPr>
             </a:pPr>
             <a:r>
-              <a:t>Asunto: Solicitud MOVA — inventario y respaldo n8n (acme-chile.cl)</a:t>
-            </a:r>
-            <a:br/>
-            <a:br/>
-            <a:r>
-              <a:t>Hola,</a:t>
-            </a:r>
-            <a:br/>
-            <a:br/>
-            <a:r>
-              <a:t>Para la auditoría MOVA en acme-chile.cl necesitamos:</a:t>
-            </a:r>
-            <a:br/>
-            <a:br/>
-            <a:r>
-              <a:t>1) TABLA de workflows en producción que sirvan al sitio o módulos MOVA:</a:t>
-            </a:r>
-            <a:br/>
-            <a:r>
-              <a:t>   · Nombre · URL webhook · Módulo · Auth · Responsable · Notas</a:t>
-            </a:r>
-            <a:br/>
-            <a:br/>
-            <a:r>
-              <a:t>2) EXPORT JSON de esos workflows activos (backup repo privado mova-n8n-workflows).</a:t>
-            </a:r>
-            <a:br/>
-            <a:br/>
-            <a:r>
-              <a:t>3) CONTEXTO: URL instancia n8n · contacto admin · webhooks sin auth · workflows que validan usuario.</a:t>
-            </a:r>
-            <a:br/>
-            <a:br/>
-            <a:r>
-              <a:t>No enviar contraseñas ni tokens por correo.</a:t>
-            </a:r>
-            <a:br/>
-            <a:br/>
-            <a:r>
-              <a:t>Plazo sugerido: [FECHA]</a:t>
-            </a:r>
-            <a:br/>
-            <a:r>
-              <a:t>Contacto MOVA: [TU CORREO]</a:t>
-            </a:r>
-            <a:br/>
-            <a:br/>
-            <a:r>
-              <a:t>Gracias.</a:t>
+              <a:t>URL de la instancia n8n recibida</a:t>
+            </a:r>
+          </a:p>
+        </p:txBody>
+      </p:sp>
+      <p:sp>
+        <p:nvSpPr>
+          <p:cNvPr id="9" name="TextBox 8"/>
+          <p:cNvSpPr txBox="1"/>
+          <p:nvPr/>
+        </p:nvSpPr>
+        <p:spPr>
+          <a:xfrm>
+            <a:off x="777240" y="1764792"/>
+            <a:ext cx="411480" cy="347472"/>
+          </a:xfrm>
+          <a:prstGeom prst="rect">
+            <a:avLst/>
+          </a:prstGeom>
+          <a:noFill/>
+        </p:spPr>
+        <p:txBody>
+          <a:bodyPr wrap="square">
+            <a:spAutoFit/>
+          </a:bodyPr>
+          <a:lstStyle/>
+          <a:p>
+            <a:pPr algn="l">
+              <a:defRPr sz="1800" b="1">
+                <a:solidFill>
+                  <a:srgbClr val="BF3F00"/>
+                </a:solidFill>
+              </a:defRPr>
+            </a:pPr>
+            <a:r>
+              <a:t>○</a:t>
+            </a:r>
+          </a:p>
+        </p:txBody>
+      </p:sp>
+      <p:sp>
+        <p:nvSpPr>
+          <p:cNvPr id="10" name="TextBox 9"/>
+          <p:cNvSpPr txBox="1"/>
+          <p:nvPr/>
+        </p:nvSpPr>
+        <p:spPr>
+          <a:xfrm>
+            <a:off x="1234440" y="1764792"/>
+            <a:ext cx="10332720" cy="347472"/>
+          </a:xfrm>
+          <a:prstGeom prst="rect">
+            <a:avLst/>
+          </a:prstGeom>
+          <a:noFill/>
+        </p:spPr>
+        <p:txBody>
+          <a:bodyPr wrap="square">
+            <a:spAutoFit/>
+          </a:bodyPr>
+          <a:lstStyle/>
+          <a:p>
+            <a:pPr algn="l">
+              <a:defRPr sz="1500" b="0">
+                <a:solidFill>
+                  <a:srgbClr val="1F2328"/>
+                </a:solidFill>
+              </a:defRPr>
+            </a:pPr>
+            <a:r>
+              <a:t>Contacto admin n8n confirmado</a:t>
+            </a:r>
+          </a:p>
+        </p:txBody>
+      </p:sp>
+      <p:sp>
+        <p:nvSpPr>
+          <p:cNvPr id="11" name="TextBox 10"/>
+          <p:cNvSpPr txBox="1"/>
+          <p:nvPr/>
+        </p:nvSpPr>
+        <p:spPr>
+          <a:xfrm>
+            <a:off x="777240" y="2203704"/>
+            <a:ext cx="411480" cy="347472"/>
+          </a:xfrm>
+          <a:prstGeom prst="rect">
+            <a:avLst/>
+          </a:prstGeom>
+          <a:noFill/>
+        </p:spPr>
+        <p:txBody>
+          <a:bodyPr wrap="square">
+            <a:spAutoFit/>
+          </a:bodyPr>
+          <a:lstStyle/>
+          <a:p>
+            <a:pPr algn="l">
+              <a:defRPr sz="1800" b="1">
+                <a:solidFill>
+                  <a:srgbClr val="BF3F00"/>
+                </a:solidFill>
+              </a:defRPr>
+            </a:pPr>
+            <a:r>
+              <a:t>○</a:t>
+            </a:r>
+          </a:p>
+        </p:txBody>
+      </p:sp>
+      <p:sp>
+        <p:nvSpPr>
+          <p:cNvPr id="12" name="TextBox 11"/>
+          <p:cNvSpPr txBox="1"/>
+          <p:nvPr/>
+        </p:nvSpPr>
+        <p:spPr>
+          <a:xfrm>
+            <a:off x="1234440" y="2203704"/>
+            <a:ext cx="10332720" cy="347472"/>
+          </a:xfrm>
+          <a:prstGeom prst="rect">
+            <a:avLst/>
+          </a:prstGeom>
+          <a:noFill/>
+        </p:spPr>
+        <p:txBody>
+          <a:bodyPr wrap="square">
+            <a:spAutoFit/>
+          </a:bodyPr>
+          <a:lstStyle/>
+          <a:p>
+            <a:pPr algn="l">
+              <a:defRPr sz="1500" b="0">
+                <a:solidFill>
+                  <a:srgbClr val="1F2328"/>
+                </a:solidFill>
+              </a:defRPr>
+            </a:pPr>
+            <a:r>
+              <a:t>Listado de webhooks sin autenticación (si existen)</a:t>
+            </a:r>
+          </a:p>
+        </p:txBody>
+      </p:sp>
+      <p:sp>
+        <p:nvSpPr>
+          <p:cNvPr id="13" name="TextBox 12"/>
+          <p:cNvSpPr txBox="1"/>
+          <p:nvPr/>
+        </p:nvSpPr>
+        <p:spPr>
+          <a:xfrm>
+            <a:off x="777240" y="2642616"/>
+            <a:ext cx="411480" cy="347472"/>
+          </a:xfrm>
+          <a:prstGeom prst="rect">
+            <a:avLst/>
+          </a:prstGeom>
+          <a:noFill/>
+        </p:spPr>
+        <p:txBody>
+          <a:bodyPr wrap="square">
+            <a:spAutoFit/>
+          </a:bodyPr>
+          <a:lstStyle/>
+          <a:p>
+            <a:pPr algn="l">
+              <a:defRPr sz="1800" b="1">
+                <a:solidFill>
+                  <a:srgbClr val="BF3F00"/>
+                </a:solidFill>
+              </a:defRPr>
+            </a:pPr>
+            <a:r>
+              <a:t>○</a:t>
+            </a:r>
+          </a:p>
+        </p:txBody>
+      </p:sp>
+      <p:sp>
+        <p:nvSpPr>
+          <p:cNvPr id="14" name="TextBox 13"/>
+          <p:cNvSpPr txBox="1"/>
+          <p:nvPr/>
+        </p:nvSpPr>
+        <p:spPr>
+          <a:xfrm>
+            <a:off x="1234440" y="2642616"/>
+            <a:ext cx="10332720" cy="347472"/>
+          </a:xfrm>
+          <a:prstGeom prst="rect">
+            <a:avLst/>
+          </a:prstGeom>
+          <a:noFill/>
+        </p:spPr>
+        <p:txBody>
+          <a:bodyPr wrap="square">
+            <a:spAutoFit/>
+          </a:bodyPr>
+          <a:lstStyle/>
+          <a:p>
+            <a:pPr algn="l">
+              <a:defRPr sz="1500" b="0">
+                <a:solidFill>
+                  <a:srgbClr val="1F2328"/>
+                </a:solidFill>
+              </a:defRPr>
+            </a:pPr>
+            <a:r>
+              <a:t>Workflows que validan usuario/sesión identificados</a:t>
+            </a:r>
+          </a:p>
+        </p:txBody>
+      </p:sp>
+      <p:sp>
+        <p:nvSpPr>
+          <p:cNvPr id="15" name="TextBox 14"/>
+          <p:cNvSpPr txBox="1"/>
+          <p:nvPr/>
+        </p:nvSpPr>
+        <p:spPr>
+          <a:xfrm>
+            <a:off x="777240" y="3081528"/>
+            <a:ext cx="411480" cy="347472"/>
+          </a:xfrm>
+          <a:prstGeom prst="rect">
+            <a:avLst/>
+          </a:prstGeom>
+          <a:noFill/>
+        </p:spPr>
+        <p:txBody>
+          <a:bodyPr wrap="square">
+            <a:spAutoFit/>
+          </a:bodyPr>
+          <a:lstStyle/>
+          <a:p>
+            <a:pPr algn="l">
+              <a:defRPr sz="1800" b="1">
+                <a:solidFill>
+                  <a:srgbClr val="BF3F00"/>
+                </a:solidFill>
+              </a:defRPr>
+            </a:pPr>
+            <a:r>
+              <a:t>○</a:t>
+            </a:r>
+          </a:p>
+        </p:txBody>
+      </p:sp>
+      <p:sp>
+        <p:nvSpPr>
+          <p:cNvPr id="16" name="TextBox 15"/>
+          <p:cNvSpPr txBox="1"/>
+          <p:nvPr/>
+        </p:nvSpPr>
+        <p:spPr>
+          <a:xfrm>
+            <a:off x="1234440" y="3081528"/>
+            <a:ext cx="10332720" cy="347472"/>
+          </a:xfrm>
+          <a:prstGeom prst="rect">
+            <a:avLst/>
+          </a:prstGeom>
+          <a:noFill/>
+        </p:spPr>
+        <p:txBody>
+          <a:bodyPr wrap="square">
+            <a:spAutoFit/>
+          </a:bodyPr>
+          <a:lstStyle/>
+          <a:p>
+            <a:pPr algn="l">
+              <a:defRPr sz="1500" b="0">
+                <a:solidFill>
+                  <a:srgbClr val="1F2328"/>
+                </a:solidFill>
+              </a:defRPr>
+            </a:pPr>
+            <a:r>
+              <a:t>Decisión sobre backup automático vs manual documentada</a:t>
             </a:r>
           </a:p>
         </p:txBody>
@@ -6641,7 +7829,7 @@
               </a:defRPr>
             </a:pPr>
             <a:r>
-              <a:t>Checklist maestro — cierre del día</a:t>
+              <a:t>Qué NO pedir (o pedir con cuidado)</a:t>
             </a:r>
           </a:p>
         </p:txBody>
@@ -6676,6 +7864,1069 @@
               </a:defRPr>
             </a:pPr>
             <a:r>
+              <a:t>Evitar riesgos de seguridad</a:t>
+            </a:r>
+          </a:p>
+        </p:txBody>
+      </p:sp>
+      <p:sp>
+        <p:nvSpPr>
+          <p:cNvPr id="5" name="Rounded Rectangle 4"/>
+          <p:cNvSpPr/>
+          <p:nvPr/>
+        </p:nvSpPr>
+        <p:spPr>
+          <a:xfrm>
+            <a:off x="685800" y="1325880"/>
+            <a:ext cx="4846320" cy="594360"/>
+          </a:xfrm>
+          <a:prstGeom prst="roundRect">
+            <a:avLst/>
+          </a:prstGeom>
+          <a:solidFill>
+            <a:srgbClr val="FFE8D6"/>
+          </a:solidFill>
+          <a:ln w="12700">
+            <a:solidFill>
+              <a:srgbClr val="BF3F00"/>
+            </a:solidFill>
+          </a:ln>
+        </p:spPr>
+        <p:style>
+          <a:lnRef idx="1">
+            <a:schemeClr val="accent1"/>
+          </a:lnRef>
+          <a:fillRef idx="3">
+            <a:schemeClr val="accent1"/>
+          </a:fillRef>
+          <a:effectRef idx="2">
+            <a:schemeClr val="accent1"/>
+          </a:effectRef>
+          <a:fontRef idx="minor">
+            <a:schemeClr val="lt1"/>
+          </a:fontRef>
+        </p:style>
+        <p:txBody>
+          <a:bodyPr rtlCol="0" anchor="ctr"/>
+          <a:lstStyle/>
+          <a:p>
+            <a:pPr algn="ctr"/>
+          </a:p>
+        </p:txBody>
+      </p:sp>
+      <p:sp>
+        <p:nvSpPr>
+          <p:cNvPr id="6" name="TextBox 5"/>
+          <p:cNvSpPr txBox="1"/>
+          <p:nvPr/>
+        </p:nvSpPr>
+        <p:spPr>
+          <a:xfrm>
+            <a:off x="822960" y="1490472"/>
+            <a:ext cx="4572000" cy="320040"/>
+          </a:xfrm>
+          <a:prstGeom prst="rect">
+            <a:avLst/>
+          </a:prstGeom>
+          <a:noFill/>
+        </p:spPr>
+        <p:txBody>
+          <a:bodyPr wrap="square">
+            <a:spAutoFit/>
+          </a:bodyPr>
+          <a:lstStyle/>
+          <a:p>
+            <a:pPr algn="l">
+              <a:defRPr sz="1100" b="1">
+                <a:solidFill>
+                  <a:srgbClr val="BF3F00"/>
+                </a:solidFill>
+              </a:defRPr>
+            </a:pPr>
+            <a:r>
+              <a:t>✗  Contraseñas / API keys por correo</a:t>
+            </a:r>
+          </a:p>
+        </p:txBody>
+      </p:sp>
+      <p:sp>
+        <p:nvSpPr>
+          <p:cNvPr id="7" name="Rounded Rectangle 6"/>
+          <p:cNvSpPr/>
+          <p:nvPr/>
+        </p:nvSpPr>
+        <p:spPr>
+          <a:xfrm>
+            <a:off x="5760720" y="1325880"/>
+            <a:ext cx="5715000" cy="594360"/>
+          </a:xfrm>
+          <a:prstGeom prst="roundRect">
+            <a:avLst/>
+          </a:prstGeom>
+          <a:solidFill>
+            <a:srgbClr val="D4EDDA"/>
+          </a:solidFill>
+          <a:ln w="12700">
+            <a:solidFill>
+              <a:srgbClr val="1A7F37"/>
+            </a:solidFill>
+          </a:ln>
+        </p:spPr>
+        <p:style>
+          <a:lnRef idx="1">
+            <a:schemeClr val="accent1"/>
+          </a:lnRef>
+          <a:fillRef idx="3">
+            <a:schemeClr val="accent1"/>
+          </a:fillRef>
+          <a:effectRef idx="2">
+            <a:schemeClr val="accent1"/>
+          </a:effectRef>
+          <a:fontRef idx="minor">
+            <a:schemeClr val="lt1"/>
+          </a:fontRef>
+        </p:style>
+        <p:txBody>
+          <a:bodyPr rtlCol="0" anchor="ctr"/>
+          <a:lstStyle/>
+          <a:p>
+            <a:pPr algn="ctr"/>
+          </a:p>
+        </p:txBody>
+      </p:sp>
+      <p:sp>
+        <p:nvSpPr>
+          <p:cNvPr id="8" name="TextBox 7"/>
+          <p:cNvSpPr txBox="1"/>
+          <p:nvPr/>
+        </p:nvSpPr>
+        <p:spPr>
+          <a:xfrm>
+            <a:off x="5897880" y="1435608"/>
+            <a:ext cx="5440680" cy="411480"/>
+          </a:xfrm>
+          <a:prstGeom prst="rect">
+            <a:avLst/>
+          </a:prstGeom>
+          <a:noFill/>
+        </p:spPr>
+        <p:txBody>
+          <a:bodyPr wrap="square">
+            <a:spAutoFit/>
+          </a:bodyPr>
+          <a:lstStyle/>
+          <a:p>
+            <a:pPr algn="l">
+              <a:defRPr sz="1000" b="0">
+                <a:solidFill>
+                  <a:srgbClr val="1A7F37"/>
+                </a:solidFill>
+              </a:defRPr>
+            </a:pPr>
+            <a:r>
+              <a:t>✓  Pedir solo tipo de auth y nombre de credencial en n8n</a:t>
+            </a:r>
+          </a:p>
+        </p:txBody>
+      </p:sp>
+      <p:sp>
+        <p:nvSpPr>
+          <p:cNvPr id="9" name="Rounded Rectangle 8"/>
+          <p:cNvSpPr/>
+          <p:nvPr/>
+        </p:nvSpPr>
+        <p:spPr>
+          <a:xfrm>
+            <a:off x="685800" y="2039112"/>
+            <a:ext cx="4846320" cy="594360"/>
+          </a:xfrm>
+          <a:prstGeom prst="roundRect">
+            <a:avLst/>
+          </a:prstGeom>
+          <a:solidFill>
+            <a:srgbClr val="FFE8D6"/>
+          </a:solidFill>
+          <a:ln w="12700">
+            <a:solidFill>
+              <a:srgbClr val="BF3F00"/>
+            </a:solidFill>
+          </a:ln>
+        </p:spPr>
+        <p:style>
+          <a:lnRef idx="1">
+            <a:schemeClr val="accent1"/>
+          </a:lnRef>
+          <a:fillRef idx="3">
+            <a:schemeClr val="accent1"/>
+          </a:fillRef>
+          <a:effectRef idx="2">
+            <a:schemeClr val="accent1"/>
+          </a:effectRef>
+          <a:fontRef idx="minor">
+            <a:schemeClr val="lt1"/>
+          </a:fontRef>
+        </p:style>
+        <p:txBody>
+          <a:bodyPr rtlCol="0" anchor="ctr"/>
+          <a:lstStyle/>
+          <a:p>
+            <a:pPr algn="ctr"/>
+          </a:p>
+        </p:txBody>
+      </p:sp>
+      <p:sp>
+        <p:nvSpPr>
+          <p:cNvPr id="10" name="TextBox 9"/>
+          <p:cNvSpPr txBox="1"/>
+          <p:nvPr/>
+        </p:nvSpPr>
+        <p:spPr>
+          <a:xfrm>
+            <a:off x="822960" y="2203704"/>
+            <a:ext cx="4572000" cy="320040"/>
+          </a:xfrm>
+          <a:prstGeom prst="rect">
+            <a:avLst/>
+          </a:prstGeom>
+          <a:noFill/>
+        </p:spPr>
+        <p:txBody>
+          <a:bodyPr wrap="square">
+            <a:spAutoFit/>
+          </a:bodyPr>
+          <a:lstStyle/>
+          <a:p>
+            <a:pPr algn="l">
+              <a:defRPr sz="1100" b="1">
+                <a:solidFill>
+                  <a:srgbClr val="BF3F00"/>
+                </a:solidFill>
+              </a:defRPr>
+            </a:pPr>
+            <a:r>
+              <a:t>✗  Solo JSON o solo capturas</a:t>
+            </a:r>
+          </a:p>
+        </p:txBody>
+      </p:sp>
+      <p:sp>
+        <p:nvSpPr>
+          <p:cNvPr id="11" name="Rounded Rectangle 10"/>
+          <p:cNvSpPr/>
+          <p:nvPr/>
+        </p:nvSpPr>
+        <p:spPr>
+          <a:xfrm>
+            <a:off x="5760720" y="2039112"/>
+            <a:ext cx="5715000" cy="594360"/>
+          </a:xfrm>
+          <a:prstGeom prst="roundRect">
+            <a:avLst/>
+          </a:prstGeom>
+          <a:solidFill>
+            <a:srgbClr val="D4EDDA"/>
+          </a:solidFill>
+          <a:ln w="12700">
+            <a:solidFill>
+              <a:srgbClr val="1A7F37"/>
+            </a:solidFill>
+          </a:ln>
+        </p:spPr>
+        <p:style>
+          <a:lnRef idx="1">
+            <a:schemeClr val="accent1"/>
+          </a:lnRef>
+          <a:fillRef idx="3">
+            <a:schemeClr val="accent1"/>
+          </a:fillRef>
+          <a:effectRef idx="2">
+            <a:schemeClr val="accent1"/>
+          </a:effectRef>
+          <a:fontRef idx="minor">
+            <a:schemeClr val="lt1"/>
+          </a:fontRef>
+        </p:style>
+        <p:txBody>
+          <a:bodyPr rtlCol="0" anchor="ctr"/>
+          <a:lstStyle/>
+          <a:p>
+            <a:pPr algn="ctr"/>
+          </a:p>
+        </p:txBody>
+      </p:sp>
+      <p:sp>
+        <p:nvSpPr>
+          <p:cNvPr id="12" name="TextBox 11"/>
+          <p:cNvSpPr txBox="1"/>
+          <p:nvPr/>
+        </p:nvSpPr>
+        <p:spPr>
+          <a:xfrm>
+            <a:off x="5897880" y="2148840"/>
+            <a:ext cx="5440680" cy="411480"/>
+          </a:xfrm>
+          <a:prstGeom prst="rect">
+            <a:avLst/>
+          </a:prstGeom>
+          <a:noFill/>
+        </p:spPr>
+        <p:txBody>
+          <a:bodyPr wrap="square">
+            <a:spAutoFit/>
+          </a:bodyPr>
+          <a:lstStyle/>
+          <a:p>
+            <a:pPr algn="l">
+              <a:defRPr sz="1000" b="0">
+                <a:solidFill>
+                  <a:srgbClr val="1A7F37"/>
+                </a:solidFill>
+              </a:defRPr>
+            </a:pPr>
+            <a:r>
+              <a:t>✓  Pedir tabla + JSON + capturas (los tres)</a:t>
+            </a:r>
+          </a:p>
+        </p:txBody>
+      </p:sp>
+      <p:sp>
+        <p:nvSpPr>
+          <p:cNvPr id="13" name="Rounded Rectangle 12"/>
+          <p:cNvSpPr/>
+          <p:nvPr/>
+        </p:nvSpPr>
+        <p:spPr>
+          <a:xfrm>
+            <a:off x="685800" y="2752344"/>
+            <a:ext cx="4846320" cy="594360"/>
+          </a:xfrm>
+          <a:prstGeom prst="roundRect">
+            <a:avLst/>
+          </a:prstGeom>
+          <a:solidFill>
+            <a:srgbClr val="FFE8D6"/>
+          </a:solidFill>
+          <a:ln w="12700">
+            <a:solidFill>
+              <a:srgbClr val="BF3F00"/>
+            </a:solidFill>
+          </a:ln>
+        </p:spPr>
+        <p:style>
+          <a:lnRef idx="1">
+            <a:schemeClr val="accent1"/>
+          </a:lnRef>
+          <a:fillRef idx="3">
+            <a:schemeClr val="accent1"/>
+          </a:fillRef>
+          <a:effectRef idx="2">
+            <a:schemeClr val="accent1"/>
+          </a:effectRef>
+          <a:fontRef idx="minor">
+            <a:schemeClr val="lt1"/>
+          </a:fontRef>
+        </p:style>
+        <p:txBody>
+          <a:bodyPr rtlCol="0" anchor="ctr"/>
+          <a:lstStyle/>
+          <a:p>
+            <a:pPr algn="ctr"/>
+          </a:p>
+        </p:txBody>
+      </p:sp>
+      <p:sp>
+        <p:nvSpPr>
+          <p:cNvPr id="14" name="TextBox 13"/>
+          <p:cNvSpPr txBox="1"/>
+          <p:nvPr/>
+        </p:nvSpPr>
+        <p:spPr>
+          <a:xfrm>
+            <a:off x="822960" y="2916936"/>
+            <a:ext cx="4572000" cy="320040"/>
+          </a:xfrm>
+          <a:prstGeom prst="rect">
+            <a:avLst/>
+          </a:prstGeom>
+          <a:noFill/>
+        </p:spPr>
+        <p:txBody>
+          <a:bodyPr wrap="square">
+            <a:spAutoFit/>
+          </a:bodyPr>
+          <a:lstStyle/>
+          <a:p>
+            <a:pPr algn="l">
+              <a:defRPr sz="1100" b="1">
+                <a:solidFill>
+                  <a:srgbClr val="BF3F00"/>
+                </a:solidFill>
+              </a:defRPr>
+            </a:pPr>
+            <a:r>
+              <a:t>✗  Acceso admin n8n hoy</a:t>
+            </a:r>
+          </a:p>
+        </p:txBody>
+      </p:sp>
+      <p:sp>
+        <p:nvSpPr>
+          <p:cNvPr id="15" name="Rounded Rectangle 14"/>
+          <p:cNvSpPr/>
+          <p:nvPr/>
+        </p:nvSpPr>
+        <p:spPr>
+          <a:xfrm>
+            <a:off x="5760720" y="2752344"/>
+            <a:ext cx="5715000" cy="594360"/>
+          </a:xfrm>
+          <a:prstGeom prst="roundRect">
+            <a:avLst/>
+          </a:prstGeom>
+          <a:solidFill>
+            <a:srgbClr val="D4EDDA"/>
+          </a:solidFill>
+          <a:ln w="12700">
+            <a:solidFill>
+              <a:srgbClr val="1A7F37"/>
+            </a:solidFill>
+          </a:ln>
+        </p:spPr>
+        <p:style>
+          <a:lnRef idx="1">
+            <a:schemeClr val="accent1"/>
+          </a:lnRef>
+          <a:fillRef idx="3">
+            <a:schemeClr val="accent1"/>
+          </a:fillRef>
+          <a:effectRef idx="2">
+            <a:schemeClr val="accent1"/>
+          </a:effectRef>
+          <a:fontRef idx="minor">
+            <a:schemeClr val="lt1"/>
+          </a:fontRef>
+        </p:style>
+        <p:txBody>
+          <a:bodyPr rtlCol="0" anchor="ctr"/>
+          <a:lstStyle/>
+          <a:p>
+            <a:pPr algn="ctr"/>
+          </a:p>
+        </p:txBody>
+      </p:sp>
+      <p:sp>
+        <p:nvSpPr>
+          <p:cNvPr id="16" name="TextBox 15"/>
+          <p:cNvSpPr txBox="1"/>
+          <p:nvPr/>
+        </p:nvSpPr>
+        <p:spPr>
+          <a:xfrm>
+            <a:off x="5897880" y="2862072"/>
+            <a:ext cx="5440680" cy="411480"/>
+          </a:xfrm>
+          <a:prstGeom prst="rect">
+            <a:avLst/>
+          </a:prstGeom>
+          <a:noFill/>
+        </p:spPr>
+        <p:txBody>
+          <a:bodyPr wrap="square">
+            <a:spAutoFit/>
+          </a:bodyPr>
+          <a:lstStyle/>
+          <a:p>
+            <a:pPr algn="l">
+              <a:defRPr sz="1000" b="0">
+                <a:solidFill>
+                  <a:srgbClr val="1A7F37"/>
+                </a:solidFill>
+              </a:defRPr>
+            </a:pPr>
+            <a:r>
+              <a:t>✓  Solo listado + exports; admin puede ser después</a:t>
+            </a:r>
+          </a:p>
+        </p:txBody>
+      </p:sp>
+      <p:sp>
+        <p:nvSpPr>
+          <p:cNvPr id="17" name="Rounded Rectangle 16"/>
+          <p:cNvSpPr/>
+          <p:nvPr/>
+        </p:nvSpPr>
+        <p:spPr>
+          <a:xfrm>
+            <a:off x="685800" y="3465576"/>
+            <a:ext cx="4846320" cy="594360"/>
+          </a:xfrm>
+          <a:prstGeom prst="roundRect">
+            <a:avLst/>
+          </a:prstGeom>
+          <a:solidFill>
+            <a:srgbClr val="FFE8D6"/>
+          </a:solidFill>
+          <a:ln w="12700">
+            <a:solidFill>
+              <a:srgbClr val="BF3F00"/>
+            </a:solidFill>
+          </a:ln>
+        </p:spPr>
+        <p:style>
+          <a:lnRef idx="1">
+            <a:schemeClr val="accent1"/>
+          </a:lnRef>
+          <a:fillRef idx="3">
+            <a:schemeClr val="accent1"/>
+          </a:fillRef>
+          <a:effectRef idx="2">
+            <a:schemeClr val="accent1"/>
+          </a:effectRef>
+          <a:fontRef idx="minor">
+            <a:schemeClr val="lt1"/>
+          </a:fontRef>
+        </p:style>
+        <p:txBody>
+          <a:bodyPr rtlCol="0" anchor="ctr"/>
+          <a:lstStyle/>
+          <a:p>
+            <a:pPr algn="ctr"/>
+          </a:p>
+        </p:txBody>
+      </p:sp>
+      <p:sp>
+        <p:nvSpPr>
+          <p:cNvPr id="18" name="TextBox 17"/>
+          <p:cNvSpPr txBox="1"/>
+          <p:nvPr/>
+        </p:nvSpPr>
+        <p:spPr>
+          <a:xfrm>
+            <a:off x="822960" y="3630168"/>
+            <a:ext cx="4572000" cy="320040"/>
+          </a:xfrm>
+          <a:prstGeom prst="rect">
+            <a:avLst/>
+          </a:prstGeom>
+          <a:noFill/>
+        </p:spPr>
+        <p:txBody>
+          <a:bodyPr wrap="square">
+            <a:spAutoFit/>
+          </a:bodyPr>
+          <a:lstStyle/>
+          <a:p>
+            <a:pPr algn="l">
+              <a:defRPr sz="1100" b="1">
+                <a:solidFill>
+                  <a:srgbClr val="BF3F00"/>
+                </a:solidFill>
+              </a:defRPr>
+            </a:pPr>
+            <a:r>
+              <a:t>✗  Export con secretos embebidos</a:t>
+            </a:r>
+          </a:p>
+        </p:txBody>
+      </p:sp>
+      <p:sp>
+        <p:nvSpPr>
+          <p:cNvPr id="19" name="Rounded Rectangle 18"/>
+          <p:cNvSpPr/>
+          <p:nvPr/>
+        </p:nvSpPr>
+        <p:spPr>
+          <a:xfrm>
+            <a:off x="5760720" y="3465576"/>
+            <a:ext cx="5715000" cy="594360"/>
+          </a:xfrm>
+          <a:prstGeom prst="roundRect">
+            <a:avLst/>
+          </a:prstGeom>
+          <a:solidFill>
+            <a:srgbClr val="D4EDDA"/>
+          </a:solidFill>
+          <a:ln w="12700">
+            <a:solidFill>
+              <a:srgbClr val="1A7F37"/>
+            </a:solidFill>
+          </a:ln>
+        </p:spPr>
+        <p:style>
+          <a:lnRef idx="1">
+            <a:schemeClr val="accent1"/>
+          </a:lnRef>
+          <a:fillRef idx="3">
+            <a:schemeClr val="accent1"/>
+          </a:fillRef>
+          <a:effectRef idx="2">
+            <a:schemeClr val="accent1"/>
+          </a:effectRef>
+          <a:fontRef idx="minor">
+            <a:schemeClr val="lt1"/>
+          </a:fontRef>
+        </p:style>
+        <p:txBody>
+          <a:bodyPr rtlCol="0" anchor="ctr"/>
+          <a:lstStyle/>
+          <a:p>
+            <a:pPr algn="ctr"/>
+          </a:p>
+        </p:txBody>
+      </p:sp>
+      <p:sp>
+        <p:nvSpPr>
+          <p:cNvPr id="20" name="TextBox 19"/>
+          <p:cNvSpPr txBox="1"/>
+          <p:nvPr/>
+        </p:nvSpPr>
+        <p:spPr>
+          <a:xfrm>
+            <a:off x="5897880" y="3575304"/>
+            <a:ext cx="5440680" cy="411480"/>
+          </a:xfrm>
+          <a:prstGeom prst="rect">
+            <a:avLst/>
+          </a:prstGeom>
+          <a:noFill/>
+        </p:spPr>
+        <p:txBody>
+          <a:bodyPr wrap="square">
+            <a:spAutoFit/>
+          </a:bodyPr>
+          <a:lstStyle/>
+          <a:p>
+            <a:pPr algn="l">
+              <a:defRPr sz="1000" b="0">
+                <a:solidFill>
+                  <a:srgbClr val="1A7F37"/>
+                </a:solidFill>
+              </a:defRPr>
+            </a:pPr>
+            <a:r>
+              <a:t>✓  Export estándar; credenciales documentadas aparte en n8n</a:t>
+            </a:r>
+          </a:p>
+        </p:txBody>
+      </p:sp>
+    </p:spTree>
+  </p:cSld>
+  <p:clrMapOvr>
+    <a:masterClrMapping/>
+  </p:clrMapOvr>
+</p:sld>
+</file>
+
+<file path=ppt/slides/slide16.xml><?xml version="1.0" encoding="utf-8"?>
+<p:sld xmlns:a="http://schemas.openxmlformats.org/drawingml/2006/main" xmlns:p="http://schemas.openxmlformats.org/presentationml/2006/main" xmlns:r="http://schemas.openxmlformats.org/officeDocument/2006/relationships">
+  <p:cSld>
+    <p:bg>
+      <p:bgPr>
+        <a:solidFill>
+          <a:srgbClr val="E8F6F8"/>
+        </a:solidFill>
+        <a:effectLst/>
+      </p:bgPr>
+    </p:bg>
+    <p:spTree>
+      <p:nvGrpSpPr>
+        <p:cNvPr id="1" name=""/>
+        <p:cNvGrpSpPr/>
+        <p:nvPr/>
+      </p:nvGrpSpPr>
+      <p:grpSpPr/>
+      <p:sp>
+        <p:nvSpPr>
+          <p:cNvPr id="2" name="Rectangle 1"/>
+          <p:cNvSpPr/>
+          <p:nvPr/>
+        </p:nvSpPr>
+        <p:spPr>
+          <a:xfrm>
+            <a:off x="0" y="0"/>
+            <a:ext cx="12191695" cy="960120"/>
+          </a:xfrm>
+          <a:prstGeom prst="rect">
+            <a:avLst/>
+          </a:prstGeom>
+          <a:solidFill>
+            <a:srgbClr val="4A7A80"/>
+          </a:solidFill>
+          <a:ln>
+            <a:noFill/>
+          </a:ln>
+        </p:spPr>
+        <p:style>
+          <a:lnRef idx="1">
+            <a:schemeClr val="accent1"/>
+          </a:lnRef>
+          <a:fillRef idx="3">
+            <a:schemeClr val="accent1"/>
+          </a:fillRef>
+          <a:effectRef idx="2">
+            <a:schemeClr val="accent1"/>
+          </a:effectRef>
+          <a:fontRef idx="minor">
+            <a:schemeClr val="lt1"/>
+          </a:fontRef>
+        </p:style>
+        <p:txBody>
+          <a:bodyPr rtlCol="0" anchor="ctr"/>
+          <a:lstStyle/>
+          <a:p>
+            <a:pPr algn="ctr"/>
+          </a:p>
+        </p:txBody>
+      </p:sp>
+      <p:sp>
+        <p:nvSpPr>
+          <p:cNvPr id="3" name="TextBox 2"/>
+          <p:cNvSpPr txBox="1"/>
+          <p:nvPr/>
+        </p:nvSpPr>
+        <p:spPr>
+          <a:xfrm>
+            <a:off x="502920" y="164592"/>
+            <a:ext cx="8686800" cy="457200"/>
+          </a:xfrm>
+          <a:prstGeom prst="rect">
+            <a:avLst/>
+          </a:prstGeom>
+          <a:noFill/>
+        </p:spPr>
+        <p:txBody>
+          <a:bodyPr wrap="square">
+            <a:spAutoFit/>
+          </a:bodyPr>
+          <a:lstStyle/>
+          <a:p>
+            <a:pPr algn="l">
+              <a:defRPr sz="2400" b="1">
+                <a:solidFill>
+                  <a:srgbClr val="FFFFFF"/>
+                </a:solidFill>
+              </a:defRPr>
+            </a:pPr>
+            <a:r>
+              <a:t>Texto listo para enviar al equipo n8n</a:t>
+            </a:r>
+          </a:p>
+        </p:txBody>
+      </p:sp>
+      <p:sp>
+        <p:nvSpPr>
+          <p:cNvPr id="4" name="TextBox 3"/>
+          <p:cNvSpPr txBox="1"/>
+          <p:nvPr/>
+        </p:nvSpPr>
+        <p:spPr>
+          <a:xfrm>
+            <a:off x="502920" y="566928"/>
+            <a:ext cx="8686800" cy="320040"/>
+          </a:xfrm>
+          <a:prstGeom prst="rect">
+            <a:avLst/>
+          </a:prstGeom>
+          <a:noFill/>
+        </p:spPr>
+        <p:txBody>
+          <a:bodyPr wrap="square">
+            <a:spAutoFit/>
+          </a:bodyPr>
+          <a:lstStyle/>
+          <a:p>
+            <a:pPr algn="l">
+              <a:defRPr sz="1300" b="0">
+                <a:solidFill>
+                  <a:srgbClr val="E8F6F8"/>
+                </a:solidFill>
+              </a:defRPr>
+            </a:pPr>
+            <a:r>
+              <a:t>Copiar y pegar en correo</a:t>
+            </a:r>
+          </a:p>
+        </p:txBody>
+      </p:sp>
+      <p:sp>
+        <p:nvSpPr>
+          <p:cNvPr id="5" name="Rounded Rectangle 4"/>
+          <p:cNvSpPr/>
+          <p:nvPr/>
+        </p:nvSpPr>
+        <p:spPr>
+          <a:xfrm>
+            <a:off x="685800" y="1234440"/>
+            <a:ext cx="10789920" cy="5029200"/>
+          </a:xfrm>
+          <a:prstGeom prst="roundRect">
+            <a:avLst/>
+          </a:prstGeom>
+          <a:solidFill>
+            <a:srgbClr val="FFFFFF"/>
+          </a:solidFill>
+          <a:ln w="25400">
+            <a:solidFill>
+              <a:srgbClr val="4A7A80"/>
+            </a:solidFill>
+          </a:ln>
+        </p:spPr>
+        <p:style>
+          <a:lnRef idx="1">
+            <a:schemeClr val="accent1"/>
+          </a:lnRef>
+          <a:fillRef idx="3">
+            <a:schemeClr val="accent1"/>
+          </a:fillRef>
+          <a:effectRef idx="2">
+            <a:schemeClr val="accent1"/>
+          </a:effectRef>
+          <a:fontRef idx="minor">
+            <a:schemeClr val="lt1"/>
+          </a:fontRef>
+        </p:style>
+        <p:txBody>
+          <a:bodyPr rtlCol="0" anchor="ctr"/>
+          <a:lstStyle/>
+          <a:p>
+            <a:pPr algn="ctr"/>
+          </a:p>
+        </p:txBody>
+      </p:sp>
+      <p:sp>
+        <p:nvSpPr>
+          <p:cNvPr id="6" name="TextBox 5"/>
+          <p:cNvSpPr txBox="1"/>
+          <p:nvPr/>
+        </p:nvSpPr>
+        <p:spPr>
+          <a:xfrm>
+            <a:off x="868680" y="1371600"/>
+            <a:ext cx="10424160" cy="4754880"/>
+          </a:xfrm>
+          <a:prstGeom prst="rect">
+            <a:avLst/>
+          </a:prstGeom>
+          <a:noFill/>
+        </p:spPr>
+        <p:txBody>
+          <a:bodyPr wrap="square">
+            <a:spAutoFit/>
+          </a:bodyPr>
+          <a:lstStyle/>
+          <a:p>
+            <a:pPr algn="l">
+              <a:defRPr sz="1100" b="0">
+                <a:solidFill>
+                  <a:srgbClr val="1F2328"/>
+                </a:solidFill>
+              </a:defRPr>
+            </a:pPr>
+            <a:r>
+              <a:t>Asunto: Solicitud MOVA — inventario y respaldo n8n (acme-chile.cl)</a:t>
+            </a:r>
+            <a:br/>
+            <a:br/>
+            <a:r>
+              <a:t>Hola,</a:t>
+            </a:r>
+            <a:br/>
+            <a:br/>
+            <a:r>
+              <a:t>Para la auditoría MOVA en acme-chile.cl necesitamos:</a:t>
+            </a:r>
+            <a:br/>
+            <a:br/>
+            <a:r>
+              <a:t>1) TABLA de workflows en producción que sirvan al sitio o módulos MOVA:</a:t>
+            </a:r>
+            <a:br/>
+            <a:r>
+              <a:t>   · Nombre · URL webhook · Módulo · Auth · Responsable · Notas</a:t>
+            </a:r>
+            <a:br/>
+            <a:br/>
+            <a:r>
+              <a:t>2) EXPORT JSON de esos workflows activos (backup repo privado mova-n8n-workflows).</a:t>
+            </a:r>
+            <a:br/>
+            <a:br/>
+            <a:r>
+              <a:t>3) CAPTURAS por workflow activo:</a:t>
+            </a:r>
+            <a:br/>
+            <a:r>
+              <a:t>   · Lista workflows · canvas completo · nodo Webhook</a:t>
+            </a:r>
+            <a:br/>
+            <a:r>
+              <a:t>   · nodos validación auth · ejecución Success (opcional)</a:t>
+            </a:r>
+            <a:br/>
+            <a:r>
+              <a:t>   Tapar secretos antes de enviar.</a:t>
+            </a:r>
+            <a:br/>
+            <a:br/>
+            <a:r>
+              <a:t>4) CONTEXTO: URL instancia n8n · contacto admin · webhooks sin auth.</a:t>
+            </a:r>
+            <a:br/>
+            <a:br/>
+            <a:r>
+              <a:t>No enviar contraseñas ni tokens por correo.</a:t>
+            </a:r>
+            <a:br/>
+            <a:br/>
+            <a:r>
+              <a:t>Plazo sugerido: [FECHA]</a:t>
+            </a:r>
+            <a:br/>
+            <a:r>
+              <a:t>Contacto MOVA: [TU CORREO]</a:t>
+            </a:r>
+            <a:br/>
+            <a:br/>
+            <a:r>
+              <a:t>Gracias.</a:t>
+            </a:r>
+          </a:p>
+        </p:txBody>
+      </p:sp>
+    </p:spTree>
+  </p:cSld>
+  <p:clrMapOvr>
+    <a:masterClrMapping/>
+  </p:clrMapOvr>
+</p:sld>
+</file>
+
+<file path=ppt/slides/slide17.xml><?xml version="1.0" encoding="utf-8"?>
+<p:sld xmlns:a="http://schemas.openxmlformats.org/drawingml/2006/main" xmlns:p="http://schemas.openxmlformats.org/presentationml/2006/main" xmlns:r="http://schemas.openxmlformats.org/officeDocument/2006/relationships">
+  <p:cSld>
+    <p:bg>
+      <p:bgPr>
+        <a:solidFill>
+          <a:srgbClr val="E8F6F8"/>
+        </a:solidFill>
+        <a:effectLst/>
+      </p:bgPr>
+    </p:bg>
+    <p:spTree>
+      <p:nvGrpSpPr>
+        <p:cNvPr id="1" name=""/>
+        <p:cNvGrpSpPr/>
+        <p:nvPr/>
+      </p:nvGrpSpPr>
+      <p:grpSpPr/>
+      <p:sp>
+        <p:nvSpPr>
+          <p:cNvPr id="2" name="Rectangle 1"/>
+          <p:cNvSpPr/>
+          <p:nvPr/>
+        </p:nvSpPr>
+        <p:spPr>
+          <a:xfrm>
+            <a:off x="0" y="0"/>
+            <a:ext cx="12191695" cy="960120"/>
+          </a:xfrm>
+          <a:prstGeom prst="rect">
+            <a:avLst/>
+          </a:prstGeom>
+          <a:solidFill>
+            <a:srgbClr val="4A7A80"/>
+          </a:solidFill>
+          <a:ln>
+            <a:noFill/>
+          </a:ln>
+        </p:spPr>
+        <p:style>
+          <a:lnRef idx="1">
+            <a:schemeClr val="accent1"/>
+          </a:lnRef>
+          <a:fillRef idx="3">
+            <a:schemeClr val="accent1"/>
+          </a:fillRef>
+          <a:effectRef idx="2">
+            <a:schemeClr val="accent1"/>
+          </a:effectRef>
+          <a:fontRef idx="minor">
+            <a:schemeClr val="lt1"/>
+          </a:fontRef>
+        </p:style>
+        <p:txBody>
+          <a:bodyPr rtlCol="0" anchor="ctr"/>
+          <a:lstStyle/>
+          <a:p>
+            <a:pPr algn="ctr"/>
+          </a:p>
+        </p:txBody>
+      </p:sp>
+      <p:sp>
+        <p:nvSpPr>
+          <p:cNvPr id="3" name="TextBox 2"/>
+          <p:cNvSpPr txBox="1"/>
+          <p:nvPr/>
+        </p:nvSpPr>
+        <p:spPr>
+          <a:xfrm>
+            <a:off x="502920" y="164592"/>
+            <a:ext cx="8686800" cy="457200"/>
+          </a:xfrm>
+          <a:prstGeom prst="rect">
+            <a:avLst/>
+          </a:prstGeom>
+          <a:noFill/>
+        </p:spPr>
+        <p:txBody>
+          <a:bodyPr wrap="square">
+            <a:spAutoFit/>
+          </a:bodyPr>
+          <a:lstStyle/>
+          <a:p>
+            <a:pPr algn="l">
+              <a:defRPr sz="2400" b="1">
+                <a:solidFill>
+                  <a:srgbClr val="FFFFFF"/>
+                </a:solidFill>
+              </a:defRPr>
+            </a:pPr>
+            <a:r>
+              <a:t>Checklist maestro — cierre del día</a:t>
+            </a:r>
+          </a:p>
+        </p:txBody>
+      </p:sp>
+      <p:sp>
+        <p:nvSpPr>
+          <p:cNvPr id="4" name="TextBox 3"/>
+          <p:cNvSpPr txBox="1"/>
+          <p:nvPr/>
+        </p:nvSpPr>
+        <p:spPr>
+          <a:xfrm>
+            <a:off x="502920" y="566928"/>
+            <a:ext cx="8686800" cy="320040"/>
+          </a:xfrm>
+          <a:prstGeom prst="rect">
+            <a:avLst/>
+          </a:prstGeom>
+          <a:noFill/>
+        </p:spPr>
+        <p:txBody>
+          <a:bodyPr wrap="square">
+            <a:spAutoFit/>
+          </a:bodyPr>
+          <a:lstStyle/>
+          <a:p>
+            <a:pPr algn="l">
+              <a:defRPr sz="1300" b="0">
+                <a:solidFill>
+                  <a:srgbClr val="E8F6F8"/>
+                </a:solidFill>
+              </a:defRPr>
+            </a:pPr>
+            <a:r>
               <a:t>GitHub + solicitud n8n enviada</a:t>
             </a:r>
           </a:p>
@@ -6746,7 +8997,7 @@
               </a:defRPr>
             </a:pPr>
             <a:r>
-              <a:t>Bloque A — Cuenta GitHub creada y verificada</a:t>
+              <a:t>Paso 1 — Cuenta GitHub creada y verificada</a:t>
             </a:r>
           </a:p>
         </p:txBody>
@@ -6816,7 +9067,7 @@
               </a:defRPr>
             </a:pPr>
             <a:r>
-              <a:t>Bloque B — Repo mova-n8n-workflows privado creado · URL anotada</a:t>
+              <a:t>Paso 2 — Repo mova-n8n-workflows privado · URL anotada</a:t>
             </a:r>
           </a:p>
         </p:txBody>
@@ -6886,7 +9137,7 @@
               </a:defRPr>
             </a:pPr>
             <a:r>
-              <a:t>Pedido C1 — Solicitud tabla inventario n8n enviada</a:t>
+              <a:t>Paso 3 — Correo n8n enviado (tabla + JSON + capturas)</a:t>
             </a:r>
           </a:p>
         </p:txBody>
@@ -6956,7 +9207,7 @@
               </a:defRPr>
             </a:pPr>
             <a:r>
-              <a:t>Pedido C2 — Solicitud export JSON incluida en el correo</a:t>
+              <a:t>Capturas requeridas listadas en el correo</a:t>
             </a:r>
           </a:p>
         </p:txBody>
@@ -7026,7 +9277,7 @@
               </a:defRPr>
             </a:pPr>
             <a:r>
-              <a:t>Pedido C3 — Solicitud contexto complementario incluida</a:t>
+              <a:t>Ficha MOVA actualizada (GitHub + repo + contacto n8n)</a:t>
             </a:r>
           </a:p>
         </p:txBody>
@@ -7096,7 +9347,7 @@
               </a:defRPr>
             </a:pPr>
             <a:r>
-              <a:t>Ficha MOVA actualizada (credenciales GitHub + URL repo)</a:t>
+              <a:t>Seguimiento agendado cuando responda el equipo n8n</a:t>
             </a:r>
           </a:p>
         </p:txBody>
@@ -7166,7 +9417,7 @@
               </a:defRPr>
             </a:pPr>
             <a:r>
-              <a:t>Seguimiento agendado para cuando responda el equipo n8n</a:t>
+              <a:t>Inventario-MOVA-modulos.md listo para columna n8n</a:t>
             </a:r>
           </a:p>
         </p:txBody>
@@ -7236,7 +9487,7 @@
               </a:defRPr>
             </a:pPr>
             <a:r>
-              <a:t>Continuar mova_auth (D2 cerrado / D3 archivos núcleo) en paralelo</a:t>
+              <a:t>Continuar mova_auth (D3 archivos núcleo) en paralelo</a:t>
             </a:r>
           </a:p>
         </p:txBody>
@@ -7271,7 +9522,7 @@
               </a:defRPr>
             </a:pPr>
             <a:r>
-              <a:t>Entregable: MOVA-GitHub-N8n-Checklist.pptx · .pdf</a:t>
+              <a:t>Guías: github-cuenta.html · github-repo.html · github-n8n.html</a:t>
             </a:r>
           </a:p>
         </p:txBody>
@@ -7410,7 +9661,7 @@
               </a:defRPr>
             </a:pPr>
             <a:r>
-              <a:t>Tres bloques + checklist por cada uno</a:t>
+              <a:t>Tres pasos + checklist por cada uno</a:t>
             </a:r>
           </a:p>
         </p:txBody>
@@ -7488,7 +9739,7 @@
               </a:defRPr>
             </a:pPr>
             <a:r>
-              <a:t>A</a:t>
+              <a:t>1</a:t>
             </a:r>
           </a:p>
         </p:txBody>
@@ -7681,7 +9932,7 @@
               </a:defRPr>
             </a:pPr>
             <a:r>
-              <a:t>B</a:t>
+              <a:t>2</a:t>
             </a:r>
           </a:p>
         </p:txBody>
@@ -7874,7 +10125,7 @@
               </a:defRPr>
             </a:pPr>
             <a:r>
-              <a:t>C</a:t>
+              <a:t>3</a:t>
             </a:r>
           </a:p>
         </p:txBody>
@@ -7989,7 +10240,7 @@
               </a:defRPr>
             </a:pPr>
             <a:r>
-              <a:t>Tabla inventario + export JSON + contexto (3 pedidos)</a:t>
+              <a:t>Tabla + JSON + capturas por workflow · github-n8n.html</a:t>
             </a:r>
           </a:p>
         </p:txBody>
@@ -13272,7 +15523,7 @@
               </a:defRPr>
             </a:pPr>
             <a:r>
-              <a:t>Guía detallada: github-repo.html · MOVA-GitHub-Paso2-Repo-Privado.pdf</a:t>
+              <a:t>Guía detallada: github-repo.html · Paso 3 → github-n8n.html</a:t>
             </a:r>
           </a:p>
         </p:txBody>

</xml_diff>